<commit_message>
Take the reviewed English into the tour, and follow it in Azerbaijani
The English points reworded in review are taken as written, with a full
stop added where one was missing, and the Azerbaijani follows them. The
points dropped in review go in both languages, and so do their markers
on the screens: land per crop, the variety key and land under trees,
and the water cause on the actions page. The closing line under the
last page's cards goes too, so it is now drawn only when there is one.

Co-Authored-By: Claude Opus 5.5 <noreply@anthropic.com>
Claude-Session: https://claude.ai/code/session_01WHgKPmXqEP88MYZfvkHt9R
</commit_message>
<xml_diff>
--- a/docs/ADAFSA_Platform_Tour_EN_AZ.pptx
+++ b/docs/ADAFSA_Platform_Tour_EN_AZ.pptx
@@ -602,15 +602,15 @@
               <a:rPr lang="en-US" dirty="0"/>
               <a:t>All your farms on one page
 The first page. It shows what is grown in the whole region, and where.
-1. The menu — Every part of the website. Point at an icon to see its pages.
-2. Choose what to count — A region, and the crop groups.
-3. The big numbers — Farms, land, and land in use. 10 dunums = 1 hectare.
+1. The menu — Flexible modules and in-depth navigation.
+2. Extensive filtering — Analyse farms that grow specific crops or trees.
+3. At a glance metrics — Understand how many farms are tracked, and how much area is being used.
 4. Where the farms are — Each circle is a group of farms. Zoom in to split it.
 Bütün təsərrüfatlar bir səhifədə
 İlk səhifə. Bütün bölgədə nəyin və harada becərildiyini göstərir.
-1. Menyu — Saytın bütün bölmələri. Səhifələri görmək üçün ikonun üzərinə gəlin.
-2. Nəyi sayacağınızı seçin — Bölgə və bitki qrupları.
-3. Əsas rəqəmlər — Təsərrüfatlar, torpaq və istifadə olunan torpaq. 10 dönüm = 1 hektar.
+1. Menyu — Çevik modullar və ətraflı naviqasiya.
+2. Geniş filtrləmə — Müəyyən bitki və ya ağac becərən təsərrüfatları təhlil edin.
+3. Bir baxışda göstəricilər — Neçə təsərrüfatın izləndiyini və nə qədər ərazinin istifadə olunduğunu anlayın.
 4. Təsərrüfatlar haradadır — Hər dairə bir qrup təsərrüfatdır. Bölmək üçün yaxınlaşdırın.</a:t>
             </a:r>
             <a:endParaRPr lang="en-US" dirty="0"/>
@@ -701,14 +701,12 @@
               <a:rPr lang="en-US" dirty="0"/>
               <a:t>What grows where
 The field crops on every farm: which crop, on how much land, and on which farm.
-1. Open a crop group — Tick a group, or open it to pick one crop.
+1. Filter specific crop groups — Tick a group, or open it to pick specific crops.
 2. Coloured by crop — Each dot is a farm, in the colour of its main crop.
-3. Land for each crop — Dunums and share. Click a group to see its crops.
 Harada nə becərilir
 Hər təsərrüfatda tarla bitkiləri: hansı bitki, nə qədər torpaqda və hansı təsərrüfatda.
-1. Bitki qrupunu açın — Qrupu seçin və ya açıb bir bitki seçin.
-2. Bitkiyə görə rəng — Hər nöqtə bir təsərrüfatdır, əsas bitkisinin rəngində.
-3. Hər bitkinin torpağı — Dönüm və pay. Bitkiləri görmək üçün qrupa klikləyin.</a:t>
+1. Bitki qruplarını filtrləyin — Qrupu seçin və ya açıb konkret bitkiləri seçin.
+2. Bitkiyə görə rəng — Hər nöqtə bir təsərrüfatdır, əsas bitkisinin rəngində.</a:t>
             </a:r>
             <a:endParaRPr lang="en-US" dirty="0"/>
           </a:p>
@@ -798,16 +796,12 @@
               <a:rPr lang="en-US" dirty="0"/>
               <a:t>Every tree, in every orchard
 The satellite finds each tree, counts it, and tells its kind.
-1. All trees, counted — Date palms, fruit trees and forest trees.
+1. All trees, counted — From fruit trees to forest trees.
 2. One dot, one tree — Zoom in to a farm. The colour of a dot is its variety.
-3. Which variety — Each colour is one variety of palm or fruit tree.
-4. Land under trees — Dunums of palms, fruit trees and forest trees.
 Hər bağda hər ağac
 Peyk hər ağacı tapır, sayır və onun növünü deyir.
-1. Bütün ağaclar sayılır — Xurma palmaları, meyvə və meşə ağacları.
-2. Bir nöqtə, bir ağac — Təsərrüfata yaxınlaşın. Nöqtənin rəngi sortu göstərir.
-3. Hansı sort — Hər rəng bir xurma və ya meyvə ağacı sortudur.
-4. Ağacların torpağı — Xurma, meyvə və meşə ağaclarının dönümü.</a:t>
+1. Bütün ağaclar sayılır — Meyvə ağaclarından meşə ağaclarına qədər.
+2. Bir nöqtə, bir ağac — Təsərrüfata yaxınlaşın. Nöqtənin rəngi sortu göstərir.</a:t>
             </a:r>
             <a:endParaRPr lang="en-US" dirty="0"/>
           </a:p>
@@ -897,14 +891,14 @@
               <a:rPr lang="en-US" dirty="0"/>
               <a:t>Plant health, farm by farm
 The satellite measures how green and strong the trees are. A low score is an early warning.
-1. A score from 0 to 100 — For palms and fruit trees. 80 or more is healthy.
-2. Who to visit first — Here: 6 farms have very stressed trees.
+1. A score from 0 to 100 — For crops and fruit trees.
+2. Who to visit first — Here: 6 farms have very stressed crops.
 3. Four levels — Healthy, fair, stressed, very stressed.
 4. Health on the map — The score of each area. Zoom in to see each farm.
 Hər təsərrüfatda bitki sağlamlığı
 Peyk ağacların nə qədər yaşıl və güclü olduğunu ölçür. Aşağı bal erkən xəbərdarlıqdır.
-1. 0-dan 100-ə qədər bal — Xurma və meyvə ağacları üçün. 80 və yuxarı sağlamdır.
-2. Əvvəlcə kimə baş çəkmək — Burada: 6 təsərrüfatda ağaclar çox zəifdir.
+1. 0-dan 100-ə qədər bal — Əkinlər və meyvə ağacları üçün.
+2. Əvvəlcə kimə baş çəkmək — Burada: 6 təsərrüfatda əkinlər çox zəifdir.
 3. Dörd səviyyə — Sağlam, orta, zəif, çox zəif.
 4. Xəritədə sağlamlıq — Hər ərazinin balı. Hər təsərrüfatı görmək üçün yaxınlaşdırın.</a:t>
             </a:r>
@@ -1098,13 +1092,11 @@
 1. Most urgent first — Each problem, with a short reason.
 2. What to do — Look for lack of water, salt in the soil, or pests.
 3. Take it to the farm — Print one page for the visit.
-4. A possible cause — The farm used only 70% of the water it is allowed.
 Baldan təsərrüfat ziyarətinə
 Bu təsərrüfatda nəyi yoxlamaq lazımdır. Sayt xəstəliyin adını demir. Harada baxmağı göstərir.
 1. Ən təcili birinci — Hər problem və qısa səbəbi.
 2. Nə etməli — Su çatışmazlığını, torpaqda duzu və ya zərərvericiləri axtarın.
-3. Təsərrüfata aparın — Ziyarət üçün bir səhifə çap edin.
-4. Mümkün səbəb — Təsərrüfat ona ayrılan suyun yalnız 70 faizini istifadə edib.</a:t>
+3. Təsərrüfata aparın — Ziyarət üçün bir səhifə çap edin.</a:t>
             </a:r>
             <a:endParaRPr lang="en-US" dirty="0"/>
           </a:p>
@@ -2458,7 +2450,7 @@
                 <a:ea typeface="Calibri" pitchFamily="34" charset="-122"/>
                 <a:cs typeface="Calibri" pitchFamily="34" charset="-120"/>
               </a:rPr>
-              <a:t>Every part of the website. Point at an icon to see its pages.</a:t>
+              <a:t>Flexible modules and in-depth navigation.</a:t>
             </a:r>
             <a:endParaRPr lang="en-US" sz="1300" dirty="0"/>
           </a:p>
@@ -2545,7 +2537,7 @@
                 <a:ea typeface="Calibri" pitchFamily="34" charset="-122"/>
                 <a:cs typeface="Calibri" pitchFamily="34" charset="-120"/>
               </a:rPr>
-              <a:t>Choose what to count</a:t>
+              <a:t>Extensive filtering</a:t>
             </a:r>
             <a:endParaRPr lang="en-US" sz="1300" dirty="0"/>
           </a:p>
@@ -2562,7 +2554,7 @@
                 <a:ea typeface="Calibri" pitchFamily="34" charset="-122"/>
                 <a:cs typeface="Calibri" pitchFamily="34" charset="-120"/>
               </a:rPr>
-              <a:t>A region, and the crop groups.</a:t>
+              <a:t>Analyse farms that grow specific crops or trees.</a:t>
             </a:r>
             <a:endParaRPr lang="en-US" sz="1300" dirty="0"/>
           </a:p>
@@ -2649,7 +2641,7 @@
                 <a:ea typeface="Calibri" pitchFamily="34" charset="-122"/>
                 <a:cs typeface="Calibri" pitchFamily="34" charset="-120"/>
               </a:rPr>
-              <a:t>The big numbers</a:t>
+              <a:t>At a glance metrics</a:t>
             </a:r>
             <a:endParaRPr lang="en-US" sz="1300" dirty="0"/>
           </a:p>
@@ -2666,7 +2658,7 @@
                 <a:ea typeface="Calibri" pitchFamily="34" charset="-122"/>
                 <a:cs typeface="Calibri" pitchFamily="34" charset="-120"/>
               </a:rPr>
-              <a:t>Farms, land, and land in use. 10 dunums = 1 hectare.</a:t>
+              <a:t>Understand how many farms are tracked, and how much area is being used.</a:t>
             </a:r>
             <a:endParaRPr lang="en-US" sz="1300" dirty="0"/>
           </a:p>
@@ -2991,7 +2983,7 @@
                 <a:ea typeface="Calibri" pitchFamily="34" charset="-122"/>
                 <a:cs typeface="Calibri" pitchFamily="34" charset="-120"/>
               </a:rPr>
-              <a:t>Saytın bütün bölmələri. Səhifələri görmək üçün ikonun üzərinə gəlin.</a:t>
+              <a:t>Çevik modullar və ətraflı naviqasiya.</a:t>
             </a:r>
             <a:endParaRPr lang="en-US" sz="1300" dirty="0"/>
           </a:p>
@@ -3078,7 +3070,7 @@
                 <a:ea typeface="Calibri" pitchFamily="34" charset="-122"/>
                 <a:cs typeface="Calibri" pitchFamily="34" charset="-120"/>
               </a:rPr>
-              <a:t>Nəyi sayacağınızı seçin</a:t>
+              <a:t>Geniş filtrləmə</a:t>
             </a:r>
             <a:endParaRPr lang="en-US" sz="1300" dirty="0"/>
           </a:p>
@@ -3095,7 +3087,7 @@
                 <a:ea typeface="Calibri" pitchFamily="34" charset="-122"/>
                 <a:cs typeface="Calibri" pitchFamily="34" charset="-120"/>
               </a:rPr>
-              <a:t>Bölgə və bitki qrupları.</a:t>
+              <a:t>Müəyyən bitki və ya ağac becərən təsərrüfatları təhlil edin.</a:t>
             </a:r>
             <a:endParaRPr lang="en-US" sz="1300" dirty="0"/>
           </a:p>
@@ -3182,7 +3174,7 @@
                 <a:ea typeface="Calibri" pitchFamily="34" charset="-122"/>
                 <a:cs typeface="Calibri" pitchFamily="34" charset="-120"/>
               </a:rPr>
-              <a:t>Əsas rəqəmlər</a:t>
+              <a:t>Bir baxışda göstəricilər</a:t>
             </a:r>
             <a:endParaRPr lang="en-US" sz="1300" dirty="0"/>
           </a:p>
@@ -3199,7 +3191,7 @@
                 <a:ea typeface="Calibri" pitchFamily="34" charset="-122"/>
                 <a:cs typeface="Calibri" pitchFamily="34" charset="-120"/>
               </a:rPr>
-              <a:t>Təsərrüfatlar, torpaq və istifadə olunan torpaq. 10 dönüm = 1 hektar.</a:t>
+              <a:t>Neçə təsərrüfatın izləndiyini və nə qədər ərazinin istifadə olunduğunu anlayın.</a:t>
             </a:r>
             <a:endParaRPr lang="en-US" sz="1300" dirty="0"/>
           </a:p>
@@ -3502,7 +3494,124 @@
         </p:nvSpPr>
         <p:spPr>
           <a:xfrm>
-            <a:off x="3369353" y="5533519"/>
+            <a:off x="502920" y="457200"/>
+            <a:ext cx="5410048" cy="237744"/>
+          </a:xfrm>
+          <a:prstGeom prst="rect">
+            <a:avLst/>
+          </a:prstGeom>
+          <a:noFill/>
+          <a:ln/>
+        </p:spPr>
+        <p:txBody>
+          <a:bodyPr wrap="square" lIns="0" tIns="0" rIns="0" bIns="0" rtlCol="0" anchor="ctr"/>
+          <a:lstStyle/>
+          <a:p>
+            <a:pPr indent="0" marL="0">
+              <a:buNone/>
+            </a:pPr>
+            <a:r>
+              <a:rPr lang="en-US" sz="1000" b="1" spc="200" kern="0" dirty="0">
+                <a:solidFill>
+                  <a:srgbClr val="1B7350"/>
+                </a:solidFill>
+                <a:latin typeface="Calibri" pitchFamily="34" charset="0"/>
+                <a:ea typeface="Calibri" pitchFamily="34" charset="-122"/>
+                <a:cs typeface="Calibri" pitchFamily="34" charset="-120"/>
+              </a:rPr>
+              <a:t>ENGLISH</a:t>
+            </a:r>
+            <a:endParaRPr lang="en-US" sz="1000" dirty="0"/>
+          </a:p>
+        </p:txBody>
+      </p:sp>
+      <p:sp>
+        <p:nvSpPr>
+          <p:cNvPr id="6" name="Text 3"/>
+          <p:cNvSpPr txBox="1"/>
+          <p:nvPr/>
+        </p:nvSpPr>
+        <p:spPr>
+          <a:xfrm>
+            <a:off x="502920" y="731520"/>
+            <a:ext cx="5410048" cy="457200"/>
+          </a:xfrm>
+          <a:prstGeom prst="rect">
+            <a:avLst/>
+          </a:prstGeom>
+          <a:noFill/>
+          <a:ln/>
+        </p:spPr>
+        <p:txBody>
+          <a:bodyPr wrap="square" lIns="0" tIns="0" rIns="0" bIns="0" rtlCol="0" anchor="t"/>
+          <a:lstStyle/>
+          <a:p>
+            <a:pPr indent="0" marL="0">
+              <a:buNone/>
+            </a:pPr>
+            <a:r>
+              <a:rPr lang="en-US" sz="2400" b="1" dirty="0">
+                <a:solidFill>
+                  <a:srgbClr val="0D1411"/>
+                </a:solidFill>
+                <a:latin typeface="Calibri" pitchFamily="34" charset="0"/>
+                <a:ea typeface="Calibri" pitchFamily="34" charset="-122"/>
+                <a:cs typeface="Calibri" pitchFamily="34" charset="-120"/>
+              </a:rPr>
+              <a:t>What grows where</a:t>
+            </a:r>
+            <a:endParaRPr lang="en-US" sz="2400" dirty="0"/>
+          </a:p>
+        </p:txBody>
+      </p:sp>
+      <p:sp>
+        <p:nvSpPr>
+          <p:cNvPr id="7" name="Text 4"/>
+          <p:cNvSpPr txBox="1"/>
+          <p:nvPr/>
+        </p:nvSpPr>
+        <p:spPr>
+          <a:xfrm>
+            <a:off x="502920" y="1225296"/>
+            <a:ext cx="5410048" cy="585216"/>
+          </a:xfrm>
+          <a:prstGeom prst="rect">
+            <a:avLst/>
+          </a:prstGeom>
+          <a:noFill/>
+          <a:ln/>
+        </p:spPr>
+        <p:txBody>
+          <a:bodyPr wrap="square" lIns="0" tIns="0" rIns="0" bIns="0" rtlCol="0" anchor="t"/>
+          <a:lstStyle/>
+          <a:p>
+            <a:pPr indent="0" marL="0">
+              <a:buNone/>
+            </a:pPr>
+            <a:r>
+              <a:rPr lang="en-US" sz="1400" dirty="0">
+                <a:solidFill>
+                  <a:srgbClr val="4A5852"/>
+                </a:solidFill>
+                <a:latin typeface="Calibri" pitchFamily="34" charset="0"/>
+                <a:ea typeface="Calibri" pitchFamily="34" charset="-122"/>
+                <a:cs typeface="Calibri" pitchFamily="34" charset="-120"/>
+              </a:rPr>
+              <a:t>The field crops on every farm: which crop, on how much land, and on which farm.</a:t>
+            </a:r>
+            <a:endParaRPr lang="en-US" sz="1400" dirty="0"/>
+          </a:p>
+        </p:txBody>
+      </p:sp>
+      <p:sp>
+        <p:nvSpPr>
+          <p:cNvPr id="8" name="Text 5"/>
+          <p:cNvSpPr txBox="1"/>
+          <p:nvPr/>
+        </p:nvSpPr>
+        <p:spPr>
+          <a:xfrm>
+            <a:off x="502920" y="2261286"/>
             <a:ext cx="228600" cy="228600"/>
           </a:xfrm>
           <a:prstGeom prst="ellipse">
@@ -3533,7 +3642,7 @@
                 <a:ea typeface="Calibri" pitchFamily="34" charset="-122"/>
                 <a:cs typeface="Calibri" pitchFamily="34" charset="-120"/>
               </a:rPr>
-              <a:t>3</a:t>
+              <a:t>1</a:t>
             </a:r>
             <a:endParaRPr lang="en-US" sz="1000" dirty="0"/>
           </a:p>
@@ -3541,53 +3650,14 @@
       </p:sp>
       <p:sp>
         <p:nvSpPr>
-          <p:cNvPr id="6" name="Text 3"/>
-          <p:cNvSpPr txBox="1"/>
-          <p:nvPr/>
-        </p:nvSpPr>
-        <p:spPr>
-          <a:xfrm>
-            <a:off x="502920" y="457200"/>
-            <a:ext cx="5410048" cy="237744"/>
-          </a:xfrm>
-          <a:prstGeom prst="rect">
-            <a:avLst/>
-          </a:prstGeom>
-          <a:noFill/>
-          <a:ln/>
-        </p:spPr>
-        <p:txBody>
-          <a:bodyPr wrap="square" lIns="0" tIns="0" rIns="0" bIns="0" rtlCol="0" anchor="ctr"/>
-          <a:lstStyle/>
-          <a:p>
-            <a:pPr indent="0" marL="0">
-              <a:buNone/>
-            </a:pPr>
-            <a:r>
-              <a:rPr lang="en-US" sz="1000" b="1" spc="200" kern="0" dirty="0">
-                <a:solidFill>
-                  <a:srgbClr val="1B7350"/>
-                </a:solidFill>
-                <a:latin typeface="Calibri" pitchFamily="34" charset="0"/>
-                <a:ea typeface="Calibri" pitchFamily="34" charset="-122"/>
-                <a:cs typeface="Calibri" pitchFamily="34" charset="-120"/>
-              </a:rPr>
-              <a:t>ENGLISH</a:t>
-            </a:r>
-            <a:endParaRPr lang="en-US" sz="1000" dirty="0"/>
-          </a:p>
-        </p:txBody>
-      </p:sp>
-      <p:sp>
-        <p:nvSpPr>
-          <p:cNvPr id="7" name="Text 4"/>
-          <p:cNvSpPr txBox="1"/>
-          <p:nvPr/>
-        </p:nvSpPr>
-        <p:spPr>
-          <a:xfrm>
-            <a:off x="502920" y="731520"/>
-            <a:ext cx="5410048" cy="457200"/>
+          <p:cNvPr id="9" name="Text 6"/>
+          <p:cNvSpPr txBox="1"/>
+          <p:nvPr/>
+        </p:nvSpPr>
+        <p:spPr>
+          <a:xfrm>
+            <a:off x="832104" y="2265858"/>
+            <a:ext cx="1728216" cy="1024128"/>
           </a:xfrm>
           <a:prstGeom prst="rect">
             <a:avLst/>
@@ -3600,10 +3670,13 @@
           <a:lstStyle/>
           <a:p>
             <a:pPr indent="0" marL="0">
-              <a:buNone/>
-            </a:pPr>
-            <a:r>
-              <a:rPr lang="en-US" sz="2400" b="1" dirty="0">
+              <a:spcAft>
+                <a:spcPts val="200"/>
+              </a:spcAft>
+              <a:buNone/>
+            </a:pPr>
+            <a:r>
+              <a:rPr lang="en-US" sz="1300" b="1" dirty="0">
                 <a:solidFill>
                   <a:srgbClr val="0D1411"/>
                 </a:solidFill>
@@ -3611,38 +3684,16 @@
                 <a:ea typeface="Calibri" pitchFamily="34" charset="-122"/>
                 <a:cs typeface="Calibri" pitchFamily="34" charset="-120"/>
               </a:rPr>
-              <a:t>What grows where</a:t>
-            </a:r>
-            <a:endParaRPr lang="en-US" sz="2400" dirty="0"/>
-          </a:p>
-        </p:txBody>
-      </p:sp>
-      <p:sp>
-        <p:nvSpPr>
-          <p:cNvPr id="8" name="Text 5"/>
-          <p:cNvSpPr txBox="1"/>
-          <p:nvPr/>
-        </p:nvSpPr>
-        <p:spPr>
-          <a:xfrm>
-            <a:off x="502920" y="1225296"/>
-            <a:ext cx="5410048" cy="585216"/>
-          </a:xfrm>
-          <a:prstGeom prst="rect">
-            <a:avLst/>
-          </a:prstGeom>
-          <a:noFill/>
-          <a:ln/>
-        </p:spPr>
-        <p:txBody>
-          <a:bodyPr wrap="square" lIns="0" tIns="0" rIns="0" bIns="0" rtlCol="0" anchor="t"/>
-          <a:lstStyle/>
-          <a:p>
-            <a:pPr indent="0" marL="0">
-              <a:buNone/>
-            </a:pPr>
-            <a:r>
-              <a:rPr lang="en-US" sz="1400" dirty="0">
+              <a:t>Filter specific crop groups</a:t>
+            </a:r>
+            <a:endParaRPr lang="en-US" sz="1300" dirty="0"/>
+          </a:p>
+          <a:p>
+            <a:pPr indent="0" marL="0">
+              <a:buNone/>
+            </a:pPr>
+            <a:r>
+              <a:rPr lang="en-US" sz="1150" dirty="0">
                 <a:solidFill>
                   <a:srgbClr val="4A5852"/>
                 </a:solidFill>
@@ -3650,21 +3701,21 @@
                 <a:ea typeface="Calibri" pitchFamily="34" charset="-122"/>
                 <a:cs typeface="Calibri" pitchFamily="34" charset="-120"/>
               </a:rPr>
-              <a:t>The field crops on every farm: which crop, on how much land, and on which farm.</a:t>
-            </a:r>
-            <a:endParaRPr lang="en-US" sz="1400" dirty="0"/>
-          </a:p>
-        </p:txBody>
-      </p:sp>
-      <p:sp>
-        <p:nvSpPr>
-          <p:cNvPr id="9" name="Text 6"/>
-          <p:cNvSpPr txBox="1"/>
-          <p:nvPr/>
-        </p:nvSpPr>
-        <p:spPr>
-          <a:xfrm>
-            <a:off x="502920" y="2261286"/>
+              <a:t>Tick a group, or open it to pick specific crops.</a:t>
+            </a:r>
+            <a:endParaRPr lang="en-US" sz="1300" dirty="0"/>
+          </a:p>
+        </p:txBody>
+      </p:sp>
+      <p:sp>
+        <p:nvSpPr>
+          <p:cNvPr id="10" name="Text 7"/>
+          <p:cNvSpPr txBox="1"/>
+          <p:nvPr/>
+        </p:nvSpPr>
+        <p:spPr>
+          <a:xfrm>
+            <a:off x="502920" y="3358566"/>
             <a:ext cx="228600" cy="228600"/>
           </a:xfrm>
           <a:prstGeom prst="ellipse">
@@ -3695,7 +3746,7 @@
                 <a:ea typeface="Calibri" pitchFamily="34" charset="-122"/>
                 <a:cs typeface="Calibri" pitchFamily="34" charset="-120"/>
               </a:rPr>
-              <a:t>1</a:t>
+              <a:t>2</a:t>
             </a:r>
             <a:endParaRPr lang="en-US" sz="1000" dirty="0"/>
           </a:p>
@@ -3703,13 +3754,13 @@
       </p:sp>
       <p:sp>
         <p:nvSpPr>
-          <p:cNvPr id="10" name="Text 7"/>
-          <p:cNvSpPr txBox="1"/>
-          <p:nvPr/>
-        </p:nvSpPr>
-        <p:spPr>
-          <a:xfrm>
-            <a:off x="832104" y="2265858"/>
+          <p:cNvPr id="11" name="Text 8"/>
+          <p:cNvSpPr txBox="1"/>
+          <p:nvPr/>
+        </p:nvSpPr>
+        <p:spPr>
+          <a:xfrm>
+            <a:off x="832104" y="3363138"/>
             <a:ext cx="1728216" cy="1024128"/>
           </a:xfrm>
           <a:prstGeom prst="rect">
@@ -3737,7 +3788,7 @@
                 <a:ea typeface="Calibri" pitchFamily="34" charset="-122"/>
                 <a:cs typeface="Calibri" pitchFamily="34" charset="-120"/>
               </a:rPr>
-              <a:t>Open a crop group</a:t>
+              <a:t>Coloured by crop</a:t>
             </a:r>
             <a:endParaRPr lang="en-US" sz="1300" dirty="0"/>
           </a:p>
@@ -3754,7 +3805,7 @@
                 <a:ea typeface="Calibri" pitchFamily="34" charset="-122"/>
                 <a:cs typeface="Calibri" pitchFamily="34" charset="-120"/>
               </a:rPr>
-              <a:t>Tick a group, or open it to pick one crop.</a:t>
+              <a:t>Each dot is a farm, in the colour of its main crop.</a:t>
             </a:r>
             <a:endParaRPr lang="en-US" sz="1300" dirty="0"/>
           </a:p>
@@ -3762,13 +3813,130 @@
       </p:sp>
       <p:sp>
         <p:nvSpPr>
-          <p:cNvPr id="11" name="Text 8"/>
-          <p:cNvSpPr txBox="1"/>
-          <p:nvPr/>
-        </p:nvSpPr>
-        <p:spPr>
-          <a:xfrm>
-            <a:off x="502920" y="3358566"/>
+          <p:cNvPr id="12" name="Text 9"/>
+          <p:cNvSpPr txBox="1"/>
+          <p:nvPr/>
+        </p:nvSpPr>
+        <p:spPr>
+          <a:xfrm>
+            <a:off x="6278728" y="457200"/>
+            <a:ext cx="5410048" cy="237744"/>
+          </a:xfrm>
+          <a:prstGeom prst="rect">
+            <a:avLst/>
+          </a:prstGeom>
+          <a:noFill/>
+          <a:ln/>
+        </p:spPr>
+        <p:txBody>
+          <a:bodyPr wrap="square" lIns="0" tIns="0" rIns="0" bIns="0" rtlCol="0" anchor="ctr"/>
+          <a:lstStyle/>
+          <a:p>
+            <a:pPr indent="0" marL="0">
+              <a:buNone/>
+            </a:pPr>
+            <a:r>
+              <a:rPr lang="en-US" sz="1000" b="1" spc="200" kern="0" dirty="0">
+                <a:solidFill>
+                  <a:srgbClr val="1B7350"/>
+                </a:solidFill>
+                <a:latin typeface="Calibri" pitchFamily="34" charset="0"/>
+                <a:ea typeface="Calibri" pitchFamily="34" charset="-122"/>
+                <a:cs typeface="Calibri" pitchFamily="34" charset="-120"/>
+              </a:rPr>
+              <a:t>AZƏRBAYCANCA</a:t>
+            </a:r>
+            <a:endParaRPr lang="en-US" sz="1000" dirty="0"/>
+          </a:p>
+        </p:txBody>
+      </p:sp>
+      <p:sp>
+        <p:nvSpPr>
+          <p:cNvPr id="13" name="Text 10"/>
+          <p:cNvSpPr txBox="1"/>
+          <p:nvPr/>
+        </p:nvSpPr>
+        <p:spPr>
+          <a:xfrm>
+            <a:off x="6278728" y="731520"/>
+            <a:ext cx="5410048" cy="457200"/>
+          </a:xfrm>
+          <a:prstGeom prst="rect">
+            <a:avLst/>
+          </a:prstGeom>
+          <a:noFill/>
+          <a:ln/>
+        </p:spPr>
+        <p:txBody>
+          <a:bodyPr wrap="square" lIns="0" tIns="0" rIns="0" bIns="0" rtlCol="0" anchor="t"/>
+          <a:lstStyle/>
+          <a:p>
+            <a:pPr indent="0" marL="0">
+              <a:buNone/>
+            </a:pPr>
+            <a:r>
+              <a:rPr lang="en-US" sz="2400" b="1" dirty="0">
+                <a:solidFill>
+                  <a:srgbClr val="0D1411"/>
+                </a:solidFill>
+                <a:latin typeface="Calibri" pitchFamily="34" charset="0"/>
+                <a:ea typeface="Calibri" pitchFamily="34" charset="-122"/>
+                <a:cs typeface="Calibri" pitchFamily="34" charset="-120"/>
+              </a:rPr>
+              <a:t>Harada nə becərilir</a:t>
+            </a:r>
+            <a:endParaRPr lang="en-US" sz="2400" dirty="0"/>
+          </a:p>
+        </p:txBody>
+      </p:sp>
+      <p:sp>
+        <p:nvSpPr>
+          <p:cNvPr id="14" name="Text 11"/>
+          <p:cNvSpPr txBox="1"/>
+          <p:nvPr/>
+        </p:nvSpPr>
+        <p:spPr>
+          <a:xfrm>
+            <a:off x="6278728" y="1225296"/>
+            <a:ext cx="5410048" cy="585216"/>
+          </a:xfrm>
+          <a:prstGeom prst="rect">
+            <a:avLst/>
+          </a:prstGeom>
+          <a:noFill/>
+          <a:ln/>
+        </p:spPr>
+        <p:txBody>
+          <a:bodyPr wrap="square" lIns="0" tIns="0" rIns="0" bIns="0" rtlCol="0" anchor="t"/>
+          <a:lstStyle/>
+          <a:p>
+            <a:pPr indent="0" marL="0">
+              <a:buNone/>
+            </a:pPr>
+            <a:r>
+              <a:rPr lang="en-US" sz="1400" dirty="0">
+                <a:solidFill>
+                  <a:srgbClr val="4A5852"/>
+                </a:solidFill>
+                <a:latin typeface="Calibri" pitchFamily="34" charset="0"/>
+                <a:ea typeface="Calibri" pitchFamily="34" charset="-122"/>
+                <a:cs typeface="Calibri" pitchFamily="34" charset="-120"/>
+              </a:rPr>
+              <a:t>Hər təsərrüfatda tarla bitkiləri: hansı bitki, nə qədər torpaqda və hansı təsərrüfatda.</a:t>
+            </a:r>
+            <a:endParaRPr lang="en-US" sz="1400" dirty="0"/>
+          </a:p>
+        </p:txBody>
+      </p:sp>
+      <p:sp>
+        <p:nvSpPr>
+          <p:cNvPr id="15" name="Text 12"/>
+          <p:cNvSpPr txBox="1"/>
+          <p:nvPr/>
+        </p:nvSpPr>
+        <p:spPr>
+          <a:xfrm>
+            <a:off x="9631375" y="2261286"/>
             <a:ext cx="228600" cy="228600"/>
           </a:xfrm>
           <a:prstGeom prst="ellipse">
@@ -3799,7 +3967,7 @@
                 <a:ea typeface="Calibri" pitchFamily="34" charset="-122"/>
                 <a:cs typeface="Calibri" pitchFamily="34" charset="-120"/>
               </a:rPr>
-              <a:t>2</a:t>
+              <a:t>1</a:t>
             </a:r>
             <a:endParaRPr lang="en-US" sz="1000" dirty="0"/>
           </a:p>
@@ -3807,13 +3975,13 @@
       </p:sp>
       <p:sp>
         <p:nvSpPr>
-          <p:cNvPr id="12" name="Text 9"/>
-          <p:cNvSpPr txBox="1"/>
-          <p:nvPr/>
-        </p:nvSpPr>
-        <p:spPr>
-          <a:xfrm>
-            <a:off x="832104" y="3363138"/>
+          <p:cNvPr id="16" name="Text 13"/>
+          <p:cNvSpPr txBox="1"/>
+          <p:nvPr/>
+        </p:nvSpPr>
+        <p:spPr>
+          <a:xfrm>
+            <a:off x="9960559" y="2265858"/>
             <a:ext cx="1728216" cy="1024128"/>
           </a:xfrm>
           <a:prstGeom prst="rect">
@@ -3841,7 +4009,7 @@
                 <a:ea typeface="Calibri" pitchFamily="34" charset="-122"/>
                 <a:cs typeface="Calibri" pitchFamily="34" charset="-120"/>
               </a:rPr>
-              <a:t>Coloured by crop</a:t>
+              <a:t>Bitki qruplarını filtrləyin</a:t>
             </a:r>
             <a:endParaRPr lang="en-US" sz="1300" dirty="0"/>
           </a:p>
@@ -3858,7 +4026,7 @@
                 <a:ea typeface="Calibri" pitchFamily="34" charset="-122"/>
                 <a:cs typeface="Calibri" pitchFamily="34" charset="-120"/>
               </a:rPr>
-              <a:t>Each dot is a farm, in the colour of its main crop.</a:t>
+              <a:t>Qrupu seçin və ya açıb konkret bitkiləri seçin.</a:t>
             </a:r>
             <a:endParaRPr lang="en-US" sz="1300" dirty="0"/>
           </a:p>
@@ -3866,13 +4034,13 @@
       </p:sp>
       <p:sp>
         <p:nvSpPr>
-          <p:cNvPr id="13" name="Text 10"/>
-          <p:cNvSpPr txBox="1"/>
-          <p:nvPr/>
-        </p:nvSpPr>
-        <p:spPr>
-          <a:xfrm>
-            <a:off x="502920" y="4455846"/>
+          <p:cNvPr id="17" name="Text 14"/>
+          <p:cNvSpPr txBox="1"/>
+          <p:nvPr/>
+        </p:nvSpPr>
+        <p:spPr>
+          <a:xfrm>
+            <a:off x="9631375" y="3358566"/>
             <a:ext cx="228600" cy="228600"/>
           </a:xfrm>
           <a:prstGeom prst="ellipse">
@@ -3903,7 +4071,7 @@
                 <a:ea typeface="Calibri" pitchFamily="34" charset="-122"/>
                 <a:cs typeface="Calibri" pitchFamily="34" charset="-120"/>
               </a:rPr>
-              <a:t>3</a:t>
+              <a:t>2</a:t>
             </a:r>
             <a:endParaRPr lang="en-US" sz="1000" dirty="0"/>
           </a:p>
@@ -3911,13 +4079,13 @@
       </p:sp>
       <p:sp>
         <p:nvSpPr>
-          <p:cNvPr id="14" name="Text 11"/>
-          <p:cNvSpPr txBox="1"/>
-          <p:nvPr/>
-        </p:nvSpPr>
-        <p:spPr>
-          <a:xfrm>
-            <a:off x="832104" y="4460418"/>
+          <p:cNvPr id="18" name="Text 15"/>
+          <p:cNvSpPr txBox="1"/>
+          <p:nvPr/>
+        </p:nvSpPr>
+        <p:spPr>
+          <a:xfrm>
+            <a:off x="9960559" y="3363138"/>
             <a:ext cx="1728216" cy="1024128"/>
           </a:xfrm>
           <a:prstGeom prst="rect">
@@ -3945,7 +4113,7 @@
                 <a:ea typeface="Calibri" pitchFamily="34" charset="-122"/>
                 <a:cs typeface="Calibri" pitchFamily="34" charset="-120"/>
               </a:rPr>
-              <a:t>Land for each crop</a:t>
+              <a:t>Bitkiyə görə rəng</a:t>
             </a:r>
             <a:endParaRPr lang="en-US" sz="1300" dirty="0"/>
           </a:p>
@@ -3962,7 +4130,7 @@
                 <a:ea typeface="Calibri" pitchFamily="34" charset="-122"/>
                 <a:cs typeface="Calibri" pitchFamily="34" charset="-120"/>
               </a:rPr>
-              <a:t>Dunums and share. Click a group to see its crops.</a:t>
+              <a:t>Hər nöqtə bir təsərrüfatdır, əsas bitkisinin rəngində.</a:t>
             </a:r>
             <a:endParaRPr lang="en-US" sz="1300" dirty="0"/>
           </a:p>
@@ -3970,436 +4138,7 @@
       </p:sp>
       <p:sp>
         <p:nvSpPr>
-          <p:cNvPr id="15" name="Text 12"/>
-          <p:cNvSpPr txBox="1"/>
-          <p:nvPr/>
-        </p:nvSpPr>
-        <p:spPr>
-          <a:xfrm>
-            <a:off x="6278728" y="457200"/>
-            <a:ext cx="5410048" cy="237744"/>
-          </a:xfrm>
-          <a:prstGeom prst="rect">
-            <a:avLst/>
-          </a:prstGeom>
-          <a:noFill/>
-          <a:ln/>
-        </p:spPr>
-        <p:txBody>
-          <a:bodyPr wrap="square" lIns="0" tIns="0" rIns="0" bIns="0" rtlCol="0" anchor="ctr"/>
-          <a:lstStyle/>
-          <a:p>
-            <a:pPr indent="0" marL="0">
-              <a:buNone/>
-            </a:pPr>
-            <a:r>
-              <a:rPr lang="en-US" sz="1000" b="1" spc="200" kern="0" dirty="0">
-                <a:solidFill>
-                  <a:srgbClr val="1B7350"/>
-                </a:solidFill>
-                <a:latin typeface="Calibri" pitchFamily="34" charset="0"/>
-                <a:ea typeface="Calibri" pitchFamily="34" charset="-122"/>
-                <a:cs typeface="Calibri" pitchFamily="34" charset="-120"/>
-              </a:rPr>
-              <a:t>AZƏRBAYCANCA</a:t>
-            </a:r>
-            <a:endParaRPr lang="en-US" sz="1000" dirty="0"/>
-          </a:p>
-        </p:txBody>
-      </p:sp>
-      <p:sp>
-        <p:nvSpPr>
-          <p:cNvPr id="16" name="Text 13"/>
-          <p:cNvSpPr txBox="1"/>
-          <p:nvPr/>
-        </p:nvSpPr>
-        <p:spPr>
-          <a:xfrm>
-            <a:off x="6278728" y="731520"/>
-            <a:ext cx="5410048" cy="457200"/>
-          </a:xfrm>
-          <a:prstGeom prst="rect">
-            <a:avLst/>
-          </a:prstGeom>
-          <a:noFill/>
-          <a:ln/>
-        </p:spPr>
-        <p:txBody>
-          <a:bodyPr wrap="square" lIns="0" tIns="0" rIns="0" bIns="0" rtlCol="0" anchor="t"/>
-          <a:lstStyle/>
-          <a:p>
-            <a:pPr indent="0" marL="0">
-              <a:buNone/>
-            </a:pPr>
-            <a:r>
-              <a:rPr lang="en-US" sz="2400" b="1" dirty="0">
-                <a:solidFill>
-                  <a:srgbClr val="0D1411"/>
-                </a:solidFill>
-                <a:latin typeface="Calibri" pitchFamily="34" charset="0"/>
-                <a:ea typeface="Calibri" pitchFamily="34" charset="-122"/>
-                <a:cs typeface="Calibri" pitchFamily="34" charset="-120"/>
-              </a:rPr>
-              <a:t>Harada nə becərilir</a:t>
-            </a:r>
-            <a:endParaRPr lang="en-US" sz="2400" dirty="0"/>
-          </a:p>
-        </p:txBody>
-      </p:sp>
-      <p:sp>
-        <p:nvSpPr>
-          <p:cNvPr id="17" name="Text 14"/>
-          <p:cNvSpPr txBox="1"/>
-          <p:nvPr/>
-        </p:nvSpPr>
-        <p:spPr>
-          <a:xfrm>
-            <a:off x="6278728" y="1225296"/>
-            <a:ext cx="5410048" cy="585216"/>
-          </a:xfrm>
-          <a:prstGeom prst="rect">
-            <a:avLst/>
-          </a:prstGeom>
-          <a:noFill/>
-          <a:ln/>
-        </p:spPr>
-        <p:txBody>
-          <a:bodyPr wrap="square" lIns="0" tIns="0" rIns="0" bIns="0" rtlCol="0" anchor="t"/>
-          <a:lstStyle/>
-          <a:p>
-            <a:pPr indent="0" marL="0">
-              <a:buNone/>
-            </a:pPr>
-            <a:r>
-              <a:rPr lang="en-US" sz="1400" dirty="0">
-                <a:solidFill>
-                  <a:srgbClr val="4A5852"/>
-                </a:solidFill>
-                <a:latin typeface="Calibri" pitchFamily="34" charset="0"/>
-                <a:ea typeface="Calibri" pitchFamily="34" charset="-122"/>
-                <a:cs typeface="Calibri" pitchFamily="34" charset="-120"/>
-              </a:rPr>
-              <a:t>Hər təsərrüfatda tarla bitkiləri: hansı bitki, nə qədər torpaqda və hansı təsərrüfatda.</a:t>
-            </a:r>
-            <a:endParaRPr lang="en-US" sz="1400" dirty="0"/>
-          </a:p>
-        </p:txBody>
-      </p:sp>
-      <p:sp>
-        <p:nvSpPr>
-          <p:cNvPr id="18" name="Text 15"/>
-          <p:cNvSpPr txBox="1"/>
-          <p:nvPr/>
-        </p:nvSpPr>
-        <p:spPr>
-          <a:xfrm>
-            <a:off x="9631375" y="2261286"/>
-            <a:ext cx="228600" cy="228600"/>
-          </a:xfrm>
-          <a:prstGeom prst="ellipse">
-            <a:avLst/>
-          </a:prstGeom>
-          <a:solidFill>
-            <a:srgbClr val="114230"/>
-          </a:solidFill>
-          <a:ln w="15875">
-            <a:solidFill>
-              <a:srgbClr val="FFFFFF"/>
-            </a:solidFill>
-          </a:ln>
-        </p:spPr>
-        <p:txBody>
-          <a:bodyPr wrap="square" lIns="0" tIns="0" rIns="0" bIns="0" rtlCol="0" anchor="ctr"/>
-          <a:lstStyle/>
-          <a:p>
-            <a:pPr algn="ctr" indent="0" marL="0">
-              <a:buNone/>
-            </a:pPr>
-            <a:r>
-              <a:rPr lang="en-US" sz="1000" b="1" dirty="0">
-                <a:solidFill>
-                  <a:srgbClr val="FFFFFF"/>
-                </a:solidFill>
-                <a:latin typeface="Calibri" pitchFamily="34" charset="0"/>
-                <a:ea typeface="Calibri" pitchFamily="34" charset="-122"/>
-                <a:cs typeface="Calibri" pitchFamily="34" charset="-120"/>
-              </a:rPr>
-              <a:t>1</a:t>
-            </a:r>
-            <a:endParaRPr lang="en-US" sz="1000" dirty="0"/>
-          </a:p>
-        </p:txBody>
-      </p:sp>
-      <p:sp>
-        <p:nvSpPr>
-          <p:cNvPr id="19" name="Text 16"/>
-          <p:cNvSpPr txBox="1"/>
-          <p:nvPr/>
-        </p:nvSpPr>
-        <p:spPr>
-          <a:xfrm>
-            <a:off x="9960559" y="2265858"/>
-            <a:ext cx="1728216" cy="1024128"/>
-          </a:xfrm>
-          <a:prstGeom prst="rect">
-            <a:avLst/>
-          </a:prstGeom>
-          <a:noFill/>
-          <a:ln/>
-        </p:spPr>
-        <p:txBody>
-          <a:bodyPr wrap="square" lIns="0" tIns="0" rIns="0" bIns="0" rtlCol="0" anchor="t"/>
-          <a:lstStyle/>
-          <a:p>
-            <a:pPr indent="0" marL="0">
-              <a:spcAft>
-                <a:spcPts val="200"/>
-              </a:spcAft>
-              <a:buNone/>
-            </a:pPr>
-            <a:r>
-              <a:rPr lang="en-US" sz="1300" b="1" dirty="0">
-                <a:solidFill>
-                  <a:srgbClr val="0D1411"/>
-                </a:solidFill>
-                <a:latin typeface="Calibri" pitchFamily="34" charset="0"/>
-                <a:ea typeface="Calibri" pitchFamily="34" charset="-122"/>
-                <a:cs typeface="Calibri" pitchFamily="34" charset="-120"/>
-              </a:rPr>
-              <a:t>Bitki qrupunu açın</a:t>
-            </a:r>
-            <a:endParaRPr lang="en-US" sz="1300" dirty="0"/>
-          </a:p>
-          <a:p>
-            <a:pPr indent="0" marL="0">
-              <a:buNone/>
-            </a:pPr>
-            <a:r>
-              <a:rPr lang="en-US" sz="1150" dirty="0">
-                <a:solidFill>
-                  <a:srgbClr val="4A5852"/>
-                </a:solidFill>
-                <a:latin typeface="Calibri" pitchFamily="34" charset="0"/>
-                <a:ea typeface="Calibri" pitchFamily="34" charset="-122"/>
-                <a:cs typeface="Calibri" pitchFamily="34" charset="-120"/>
-              </a:rPr>
-              <a:t>Qrupu seçin və ya açıb bir bitki seçin.</a:t>
-            </a:r>
-            <a:endParaRPr lang="en-US" sz="1300" dirty="0"/>
-          </a:p>
-        </p:txBody>
-      </p:sp>
-      <p:sp>
-        <p:nvSpPr>
-          <p:cNvPr id="20" name="Text 17"/>
-          <p:cNvSpPr txBox="1"/>
-          <p:nvPr/>
-        </p:nvSpPr>
-        <p:spPr>
-          <a:xfrm>
-            <a:off x="9631375" y="3358566"/>
-            <a:ext cx="228600" cy="228600"/>
-          </a:xfrm>
-          <a:prstGeom prst="ellipse">
-            <a:avLst/>
-          </a:prstGeom>
-          <a:solidFill>
-            <a:srgbClr val="114230"/>
-          </a:solidFill>
-          <a:ln w="15875">
-            <a:solidFill>
-              <a:srgbClr val="FFFFFF"/>
-            </a:solidFill>
-          </a:ln>
-        </p:spPr>
-        <p:txBody>
-          <a:bodyPr wrap="square" lIns="0" tIns="0" rIns="0" bIns="0" rtlCol="0" anchor="ctr"/>
-          <a:lstStyle/>
-          <a:p>
-            <a:pPr algn="ctr" indent="0" marL="0">
-              <a:buNone/>
-            </a:pPr>
-            <a:r>
-              <a:rPr lang="en-US" sz="1000" b="1" dirty="0">
-                <a:solidFill>
-                  <a:srgbClr val="FFFFFF"/>
-                </a:solidFill>
-                <a:latin typeface="Calibri" pitchFamily="34" charset="0"/>
-                <a:ea typeface="Calibri" pitchFamily="34" charset="-122"/>
-                <a:cs typeface="Calibri" pitchFamily="34" charset="-120"/>
-              </a:rPr>
-              <a:t>2</a:t>
-            </a:r>
-            <a:endParaRPr lang="en-US" sz="1000" dirty="0"/>
-          </a:p>
-        </p:txBody>
-      </p:sp>
-      <p:sp>
-        <p:nvSpPr>
-          <p:cNvPr id="21" name="Text 18"/>
-          <p:cNvSpPr txBox="1"/>
-          <p:nvPr/>
-        </p:nvSpPr>
-        <p:spPr>
-          <a:xfrm>
-            <a:off x="9960559" y="3363138"/>
-            <a:ext cx="1728216" cy="1024128"/>
-          </a:xfrm>
-          <a:prstGeom prst="rect">
-            <a:avLst/>
-          </a:prstGeom>
-          <a:noFill/>
-          <a:ln/>
-        </p:spPr>
-        <p:txBody>
-          <a:bodyPr wrap="square" lIns="0" tIns="0" rIns="0" bIns="0" rtlCol="0" anchor="t"/>
-          <a:lstStyle/>
-          <a:p>
-            <a:pPr indent="0" marL="0">
-              <a:spcAft>
-                <a:spcPts val="200"/>
-              </a:spcAft>
-              <a:buNone/>
-            </a:pPr>
-            <a:r>
-              <a:rPr lang="en-US" sz="1300" b="1" dirty="0">
-                <a:solidFill>
-                  <a:srgbClr val="0D1411"/>
-                </a:solidFill>
-                <a:latin typeface="Calibri" pitchFamily="34" charset="0"/>
-                <a:ea typeface="Calibri" pitchFamily="34" charset="-122"/>
-                <a:cs typeface="Calibri" pitchFamily="34" charset="-120"/>
-              </a:rPr>
-              <a:t>Bitkiyə görə rəng</a:t>
-            </a:r>
-            <a:endParaRPr lang="en-US" sz="1300" dirty="0"/>
-          </a:p>
-          <a:p>
-            <a:pPr indent="0" marL="0">
-              <a:buNone/>
-            </a:pPr>
-            <a:r>
-              <a:rPr lang="en-US" sz="1150" dirty="0">
-                <a:solidFill>
-                  <a:srgbClr val="4A5852"/>
-                </a:solidFill>
-                <a:latin typeface="Calibri" pitchFamily="34" charset="0"/>
-                <a:ea typeface="Calibri" pitchFamily="34" charset="-122"/>
-                <a:cs typeface="Calibri" pitchFamily="34" charset="-120"/>
-              </a:rPr>
-              <a:t>Hər nöqtə bir təsərrüfatdır, əsas bitkisinin rəngində.</a:t>
-            </a:r>
-            <a:endParaRPr lang="en-US" sz="1300" dirty="0"/>
-          </a:p>
-        </p:txBody>
-      </p:sp>
-      <p:sp>
-        <p:nvSpPr>
-          <p:cNvPr id="22" name="Text 19"/>
-          <p:cNvSpPr txBox="1"/>
-          <p:nvPr/>
-        </p:nvSpPr>
-        <p:spPr>
-          <a:xfrm>
-            <a:off x="9631375" y="4455846"/>
-            <a:ext cx="228600" cy="228600"/>
-          </a:xfrm>
-          <a:prstGeom prst="ellipse">
-            <a:avLst/>
-          </a:prstGeom>
-          <a:solidFill>
-            <a:srgbClr val="114230"/>
-          </a:solidFill>
-          <a:ln w="15875">
-            <a:solidFill>
-              <a:srgbClr val="FFFFFF"/>
-            </a:solidFill>
-          </a:ln>
-        </p:spPr>
-        <p:txBody>
-          <a:bodyPr wrap="square" lIns="0" tIns="0" rIns="0" bIns="0" rtlCol="0" anchor="ctr"/>
-          <a:lstStyle/>
-          <a:p>
-            <a:pPr algn="ctr" indent="0" marL="0">
-              <a:buNone/>
-            </a:pPr>
-            <a:r>
-              <a:rPr lang="en-US" sz="1000" b="1" dirty="0">
-                <a:solidFill>
-                  <a:srgbClr val="FFFFFF"/>
-                </a:solidFill>
-                <a:latin typeface="Calibri" pitchFamily="34" charset="0"/>
-                <a:ea typeface="Calibri" pitchFamily="34" charset="-122"/>
-                <a:cs typeface="Calibri" pitchFamily="34" charset="-120"/>
-              </a:rPr>
-              <a:t>3</a:t>
-            </a:r>
-            <a:endParaRPr lang="en-US" sz="1000" dirty="0"/>
-          </a:p>
-        </p:txBody>
-      </p:sp>
-      <p:sp>
-        <p:nvSpPr>
-          <p:cNvPr id="23" name="Text 20"/>
-          <p:cNvSpPr txBox="1"/>
-          <p:nvPr/>
-        </p:nvSpPr>
-        <p:spPr>
-          <a:xfrm>
-            <a:off x="9960559" y="4460418"/>
-            <a:ext cx="1728216" cy="1024128"/>
-          </a:xfrm>
-          <a:prstGeom prst="rect">
-            <a:avLst/>
-          </a:prstGeom>
-          <a:noFill/>
-          <a:ln/>
-        </p:spPr>
-        <p:txBody>
-          <a:bodyPr wrap="square" lIns="0" tIns="0" rIns="0" bIns="0" rtlCol="0" anchor="t"/>
-          <a:lstStyle/>
-          <a:p>
-            <a:pPr indent="0" marL="0">
-              <a:spcAft>
-                <a:spcPts val="200"/>
-              </a:spcAft>
-              <a:buNone/>
-            </a:pPr>
-            <a:r>
-              <a:rPr lang="en-US" sz="1300" b="1" dirty="0">
-                <a:solidFill>
-                  <a:srgbClr val="0D1411"/>
-                </a:solidFill>
-                <a:latin typeface="Calibri" pitchFamily="34" charset="0"/>
-                <a:ea typeface="Calibri" pitchFamily="34" charset="-122"/>
-                <a:cs typeface="Calibri" pitchFamily="34" charset="-120"/>
-              </a:rPr>
-              <a:t>Hər bitkinin torpağı</a:t>
-            </a:r>
-            <a:endParaRPr lang="en-US" sz="1300" dirty="0"/>
-          </a:p>
-          <a:p>
-            <a:pPr indent="0" marL="0">
-              <a:buNone/>
-            </a:pPr>
-            <a:r>
-              <a:rPr lang="en-US" sz="1150" dirty="0">
-                <a:solidFill>
-                  <a:srgbClr val="4A5852"/>
-                </a:solidFill>
-                <a:latin typeface="Calibri" pitchFamily="34" charset="0"/>
-                <a:ea typeface="Calibri" pitchFamily="34" charset="-122"/>
-                <a:cs typeface="Calibri" pitchFamily="34" charset="-120"/>
-              </a:rPr>
-              <a:t>Dönüm və pay. Bitkiləri görmək üçün qrupa klikləyin.</a:t>
-            </a:r>
-            <a:endParaRPr lang="en-US" sz="1300" dirty="0"/>
-          </a:p>
-        </p:txBody>
-      </p:sp>
-      <p:sp>
-        <p:nvSpPr>
-          <p:cNvPr id="25" name="Text 21"/>
+          <p:cNvPr id="20" name="Text 16"/>
           <p:cNvSpPr txBox="1"/>
           <p:nvPr/>
         </p:nvSpPr>
@@ -4590,7 +4329,124 @@
         </p:nvSpPr>
         <p:spPr>
           <a:xfrm>
-            <a:off x="4136670" y="3458584"/>
+            <a:off x="502920" y="457200"/>
+            <a:ext cx="5410048" cy="237744"/>
+          </a:xfrm>
+          <a:prstGeom prst="rect">
+            <a:avLst/>
+          </a:prstGeom>
+          <a:noFill/>
+          <a:ln/>
+        </p:spPr>
+        <p:txBody>
+          <a:bodyPr wrap="square" lIns="0" tIns="0" rIns="0" bIns="0" rtlCol="0" anchor="ctr"/>
+          <a:lstStyle/>
+          <a:p>
+            <a:pPr indent="0" marL="0">
+              <a:buNone/>
+            </a:pPr>
+            <a:r>
+              <a:rPr lang="en-US" sz="1000" b="1" spc="200" kern="0" dirty="0">
+                <a:solidFill>
+                  <a:srgbClr val="1B7350"/>
+                </a:solidFill>
+                <a:latin typeface="Calibri" pitchFamily="34" charset="0"/>
+                <a:ea typeface="Calibri" pitchFamily="34" charset="-122"/>
+                <a:cs typeface="Calibri" pitchFamily="34" charset="-120"/>
+              </a:rPr>
+              <a:t>ENGLISH</a:t>
+            </a:r>
+            <a:endParaRPr lang="en-US" sz="1000" dirty="0"/>
+          </a:p>
+        </p:txBody>
+      </p:sp>
+      <p:sp>
+        <p:nvSpPr>
+          <p:cNvPr id="6" name="Text 3"/>
+          <p:cNvSpPr txBox="1"/>
+          <p:nvPr/>
+        </p:nvSpPr>
+        <p:spPr>
+          <a:xfrm>
+            <a:off x="502920" y="731520"/>
+            <a:ext cx="5410048" cy="457200"/>
+          </a:xfrm>
+          <a:prstGeom prst="rect">
+            <a:avLst/>
+          </a:prstGeom>
+          <a:noFill/>
+          <a:ln/>
+        </p:spPr>
+        <p:txBody>
+          <a:bodyPr wrap="square" lIns="0" tIns="0" rIns="0" bIns="0" rtlCol="0" anchor="t"/>
+          <a:lstStyle/>
+          <a:p>
+            <a:pPr indent="0" marL="0">
+              <a:buNone/>
+            </a:pPr>
+            <a:r>
+              <a:rPr lang="en-US" sz="2400" b="1" dirty="0">
+                <a:solidFill>
+                  <a:srgbClr val="0D1411"/>
+                </a:solidFill>
+                <a:latin typeface="Calibri" pitchFamily="34" charset="0"/>
+                <a:ea typeface="Calibri" pitchFamily="34" charset="-122"/>
+                <a:cs typeface="Calibri" pitchFamily="34" charset="-120"/>
+              </a:rPr>
+              <a:t>Every tree, in every orchard</a:t>
+            </a:r>
+            <a:endParaRPr lang="en-US" sz="2400" dirty="0"/>
+          </a:p>
+        </p:txBody>
+      </p:sp>
+      <p:sp>
+        <p:nvSpPr>
+          <p:cNvPr id="7" name="Text 4"/>
+          <p:cNvSpPr txBox="1"/>
+          <p:nvPr/>
+        </p:nvSpPr>
+        <p:spPr>
+          <a:xfrm>
+            <a:off x="502920" y="1225296"/>
+            <a:ext cx="5410048" cy="585216"/>
+          </a:xfrm>
+          <a:prstGeom prst="rect">
+            <a:avLst/>
+          </a:prstGeom>
+          <a:noFill/>
+          <a:ln/>
+        </p:spPr>
+        <p:txBody>
+          <a:bodyPr wrap="square" lIns="0" tIns="0" rIns="0" bIns="0" rtlCol="0" anchor="t"/>
+          <a:lstStyle/>
+          <a:p>
+            <a:pPr indent="0" marL="0">
+              <a:buNone/>
+            </a:pPr>
+            <a:r>
+              <a:rPr lang="en-US" sz="1400" dirty="0">
+                <a:solidFill>
+                  <a:srgbClr val="4A5852"/>
+                </a:solidFill>
+                <a:latin typeface="Calibri" pitchFamily="34" charset="0"/>
+                <a:ea typeface="Calibri" pitchFamily="34" charset="-122"/>
+                <a:cs typeface="Calibri" pitchFamily="34" charset="-120"/>
+              </a:rPr>
+              <a:t>The satellite finds each tree, counts it, and tells its kind.</a:t>
+            </a:r>
+            <a:endParaRPr lang="en-US" sz="1400" dirty="0"/>
+          </a:p>
+        </p:txBody>
+      </p:sp>
+      <p:sp>
+        <p:nvSpPr>
+          <p:cNvPr id="8" name="Text 5"/>
+          <p:cNvSpPr txBox="1"/>
+          <p:nvPr/>
+        </p:nvSpPr>
+        <p:spPr>
+          <a:xfrm>
+            <a:off x="502920" y="2261286"/>
             <a:ext cx="228600" cy="228600"/>
           </a:xfrm>
           <a:prstGeom prst="ellipse">
@@ -4621,7 +4477,7 @@
                 <a:ea typeface="Calibri" pitchFamily="34" charset="-122"/>
                 <a:cs typeface="Calibri" pitchFamily="34" charset="-120"/>
               </a:rPr>
-              <a:t>3</a:t>
+              <a:t>1</a:t>
             </a:r>
             <a:endParaRPr lang="en-US" sz="1000" dirty="0"/>
           </a:p>
@@ -4629,13 +4485,72 @@
       </p:sp>
       <p:sp>
         <p:nvSpPr>
-          <p:cNvPr id="6" name="Text 3"/>
-          <p:cNvSpPr txBox="1"/>
-          <p:nvPr/>
-        </p:nvSpPr>
-        <p:spPr>
-          <a:xfrm>
-            <a:off x="3369353" y="5533519"/>
+          <p:cNvPr id="9" name="Text 6"/>
+          <p:cNvSpPr txBox="1"/>
+          <p:nvPr/>
+        </p:nvSpPr>
+        <p:spPr>
+          <a:xfrm>
+            <a:off x="832104" y="2265858"/>
+            <a:ext cx="1728216" cy="1024128"/>
+          </a:xfrm>
+          <a:prstGeom prst="rect">
+            <a:avLst/>
+          </a:prstGeom>
+          <a:noFill/>
+          <a:ln/>
+        </p:spPr>
+        <p:txBody>
+          <a:bodyPr wrap="square" lIns="0" tIns="0" rIns="0" bIns="0" rtlCol="0" anchor="t"/>
+          <a:lstStyle/>
+          <a:p>
+            <a:pPr indent="0" marL="0">
+              <a:spcAft>
+                <a:spcPts val="200"/>
+              </a:spcAft>
+              <a:buNone/>
+            </a:pPr>
+            <a:r>
+              <a:rPr lang="en-US" sz="1300" b="1" dirty="0">
+                <a:solidFill>
+                  <a:srgbClr val="0D1411"/>
+                </a:solidFill>
+                <a:latin typeface="Calibri" pitchFamily="34" charset="0"/>
+                <a:ea typeface="Calibri" pitchFamily="34" charset="-122"/>
+                <a:cs typeface="Calibri" pitchFamily="34" charset="-120"/>
+              </a:rPr>
+              <a:t>All trees, counted</a:t>
+            </a:r>
+            <a:endParaRPr lang="en-US" sz="1300" dirty="0"/>
+          </a:p>
+          <a:p>
+            <a:pPr indent="0" marL="0">
+              <a:buNone/>
+            </a:pPr>
+            <a:r>
+              <a:rPr lang="en-US" sz="1150" dirty="0">
+                <a:solidFill>
+                  <a:srgbClr val="4A5852"/>
+                </a:solidFill>
+                <a:latin typeface="Calibri" pitchFamily="34" charset="0"/>
+                <a:ea typeface="Calibri" pitchFamily="34" charset="-122"/>
+                <a:cs typeface="Calibri" pitchFamily="34" charset="-120"/>
+              </a:rPr>
+              <a:t>From fruit trees to forest trees.</a:t>
+            </a:r>
+            <a:endParaRPr lang="en-US" sz="1300" dirty="0"/>
+          </a:p>
+        </p:txBody>
+      </p:sp>
+      <p:sp>
+        <p:nvSpPr>
+          <p:cNvPr id="10" name="Text 7"/>
+          <p:cNvSpPr txBox="1"/>
+          <p:nvPr/>
+        </p:nvSpPr>
+        <p:spPr>
+          <a:xfrm>
+            <a:off x="502920" y="3358566"/>
             <a:ext cx="228600" cy="228600"/>
           </a:xfrm>
           <a:prstGeom prst="ellipse">
@@ -4666,7 +4581,7 @@
                 <a:ea typeface="Calibri" pitchFamily="34" charset="-122"/>
                 <a:cs typeface="Calibri" pitchFamily="34" charset="-120"/>
               </a:rPr>
-              <a:t>4</a:t>
+              <a:t>2</a:t>
             </a:r>
             <a:endParaRPr lang="en-US" sz="1000" dirty="0"/>
           </a:p>
@@ -4674,13 +4589,72 @@
       </p:sp>
       <p:sp>
         <p:nvSpPr>
-          <p:cNvPr id="7" name="Text 4"/>
-          <p:cNvSpPr txBox="1"/>
-          <p:nvPr/>
-        </p:nvSpPr>
-        <p:spPr>
-          <a:xfrm>
-            <a:off x="502920" y="457200"/>
+          <p:cNvPr id="11" name="Text 8"/>
+          <p:cNvSpPr txBox="1"/>
+          <p:nvPr/>
+        </p:nvSpPr>
+        <p:spPr>
+          <a:xfrm>
+            <a:off x="832104" y="3363138"/>
+            <a:ext cx="1728216" cy="1024128"/>
+          </a:xfrm>
+          <a:prstGeom prst="rect">
+            <a:avLst/>
+          </a:prstGeom>
+          <a:noFill/>
+          <a:ln/>
+        </p:spPr>
+        <p:txBody>
+          <a:bodyPr wrap="square" lIns="0" tIns="0" rIns="0" bIns="0" rtlCol="0" anchor="t"/>
+          <a:lstStyle/>
+          <a:p>
+            <a:pPr indent="0" marL="0">
+              <a:spcAft>
+                <a:spcPts val="200"/>
+              </a:spcAft>
+              <a:buNone/>
+            </a:pPr>
+            <a:r>
+              <a:rPr lang="en-US" sz="1300" b="1" dirty="0">
+                <a:solidFill>
+                  <a:srgbClr val="0D1411"/>
+                </a:solidFill>
+                <a:latin typeface="Calibri" pitchFamily="34" charset="0"/>
+                <a:ea typeface="Calibri" pitchFamily="34" charset="-122"/>
+                <a:cs typeface="Calibri" pitchFamily="34" charset="-120"/>
+              </a:rPr>
+              <a:t>One dot, one tree</a:t>
+            </a:r>
+            <a:endParaRPr lang="en-US" sz="1300" dirty="0"/>
+          </a:p>
+          <a:p>
+            <a:pPr indent="0" marL="0">
+              <a:buNone/>
+            </a:pPr>
+            <a:r>
+              <a:rPr lang="en-US" sz="1150" dirty="0">
+                <a:solidFill>
+                  <a:srgbClr val="4A5852"/>
+                </a:solidFill>
+                <a:latin typeface="Calibri" pitchFamily="34" charset="0"/>
+                <a:ea typeface="Calibri" pitchFamily="34" charset="-122"/>
+                <a:cs typeface="Calibri" pitchFamily="34" charset="-120"/>
+              </a:rPr>
+              <a:t>Zoom in to a farm. The colour of a dot is its variety.</a:t>
+            </a:r>
+            <a:endParaRPr lang="en-US" sz="1300" dirty="0"/>
+          </a:p>
+        </p:txBody>
+      </p:sp>
+      <p:sp>
+        <p:nvSpPr>
+          <p:cNvPr id="12" name="Text 9"/>
+          <p:cNvSpPr txBox="1"/>
+          <p:nvPr/>
+        </p:nvSpPr>
+        <p:spPr>
+          <a:xfrm>
+            <a:off x="6278728" y="457200"/>
             <a:ext cx="5410048" cy="237744"/>
           </a:xfrm>
           <a:prstGeom prst="rect">
@@ -4705,7 +4679,7 @@
                 <a:ea typeface="Calibri" pitchFamily="34" charset="-122"/>
                 <a:cs typeface="Calibri" pitchFamily="34" charset="-120"/>
               </a:rPr>
-              <a:t>ENGLISH</a:t>
+              <a:t>AZƏRBAYCANCA</a:t>
             </a:r>
             <a:endParaRPr lang="en-US" sz="1000" dirty="0"/>
           </a:p>
@@ -4713,13 +4687,13 @@
       </p:sp>
       <p:sp>
         <p:nvSpPr>
-          <p:cNvPr id="8" name="Text 5"/>
-          <p:cNvSpPr txBox="1"/>
-          <p:nvPr/>
-        </p:nvSpPr>
-        <p:spPr>
-          <a:xfrm>
-            <a:off x="502920" y="731520"/>
+          <p:cNvPr id="13" name="Text 10"/>
+          <p:cNvSpPr txBox="1"/>
+          <p:nvPr/>
+        </p:nvSpPr>
+        <p:spPr>
+          <a:xfrm>
+            <a:off x="6278728" y="731520"/>
             <a:ext cx="5410048" cy="457200"/>
           </a:xfrm>
           <a:prstGeom prst="rect">
@@ -4744,7 +4718,7 @@
                 <a:ea typeface="Calibri" pitchFamily="34" charset="-122"/>
                 <a:cs typeface="Calibri" pitchFamily="34" charset="-120"/>
               </a:rPr>
-              <a:t>Every tree, in every orchard</a:t>
+              <a:t>Hər bağda hər ağac</a:t>
             </a:r>
             <a:endParaRPr lang="en-US" sz="2400" dirty="0"/>
           </a:p>
@@ -4752,13 +4726,13 @@
       </p:sp>
       <p:sp>
         <p:nvSpPr>
-          <p:cNvPr id="9" name="Text 6"/>
-          <p:cNvSpPr txBox="1"/>
-          <p:nvPr/>
-        </p:nvSpPr>
-        <p:spPr>
-          <a:xfrm>
-            <a:off x="502920" y="1225296"/>
+          <p:cNvPr id="14" name="Text 11"/>
+          <p:cNvSpPr txBox="1"/>
+          <p:nvPr/>
+        </p:nvSpPr>
+        <p:spPr>
+          <a:xfrm>
+            <a:off x="6278728" y="1225296"/>
             <a:ext cx="5410048" cy="585216"/>
           </a:xfrm>
           <a:prstGeom prst="rect">
@@ -4783,7 +4757,7 @@
                 <a:ea typeface="Calibri" pitchFamily="34" charset="-122"/>
                 <a:cs typeface="Calibri" pitchFamily="34" charset="-120"/>
               </a:rPr>
-              <a:t>The satellite finds each tree, counts it, and tells its kind.</a:t>
+              <a:t>Peyk hər ağacı tapır, sayır və onun növünü deyir.</a:t>
             </a:r>
             <a:endParaRPr lang="en-US" sz="1400" dirty="0"/>
           </a:p>
@@ -4791,13 +4765,13 @@
       </p:sp>
       <p:sp>
         <p:nvSpPr>
-          <p:cNvPr id="10" name="Text 7"/>
-          <p:cNvSpPr txBox="1"/>
-          <p:nvPr/>
-        </p:nvSpPr>
-        <p:spPr>
-          <a:xfrm>
-            <a:off x="502920" y="2261286"/>
+          <p:cNvPr id="15" name="Text 12"/>
+          <p:cNvSpPr txBox="1"/>
+          <p:nvPr/>
+        </p:nvSpPr>
+        <p:spPr>
+          <a:xfrm>
+            <a:off x="9631375" y="2261286"/>
             <a:ext cx="228600" cy="228600"/>
           </a:xfrm>
           <a:prstGeom prst="ellipse">
@@ -4836,14 +4810,14 @@
       </p:sp>
       <p:sp>
         <p:nvSpPr>
-          <p:cNvPr id="11" name="Text 8"/>
-          <p:cNvSpPr txBox="1"/>
-          <p:nvPr/>
-        </p:nvSpPr>
-        <p:spPr>
-          <a:xfrm>
-            <a:off x="832104" y="2265858"/>
-            <a:ext cx="1728216" cy="961726"/>
+          <p:cNvPr id="16" name="Text 13"/>
+          <p:cNvSpPr txBox="1"/>
+          <p:nvPr/>
+        </p:nvSpPr>
+        <p:spPr>
+          <a:xfrm>
+            <a:off x="9960559" y="2265858"/>
+            <a:ext cx="1728216" cy="1024128"/>
           </a:xfrm>
           <a:prstGeom prst="rect">
             <a:avLst/>
@@ -4870,7 +4844,7 @@
                 <a:ea typeface="Calibri" pitchFamily="34" charset="-122"/>
                 <a:cs typeface="Calibri" pitchFamily="34" charset="-120"/>
               </a:rPr>
-              <a:t>All trees, counted</a:t>
+              <a:t>Bütün ağaclar sayılır</a:t>
             </a:r>
             <a:endParaRPr lang="en-US" sz="1300" dirty="0"/>
           </a:p>
@@ -4887,7 +4861,7 @@
                 <a:ea typeface="Calibri" pitchFamily="34" charset="-122"/>
                 <a:cs typeface="Calibri" pitchFamily="34" charset="-120"/>
               </a:rPr>
-              <a:t>Date palms, fruit trees and forest trees.</a:t>
+              <a:t>Meyvə ağaclarından meşə ağaclarına qədər.</a:t>
             </a:r>
             <a:endParaRPr lang="en-US" sz="1300" dirty="0"/>
           </a:p>
@@ -4895,13 +4869,13 @@
       </p:sp>
       <p:sp>
         <p:nvSpPr>
-          <p:cNvPr id="12" name="Text 9"/>
-          <p:cNvSpPr txBox="1"/>
-          <p:nvPr/>
-        </p:nvSpPr>
-        <p:spPr>
-          <a:xfrm>
-            <a:off x="502920" y="3296165"/>
+          <p:cNvPr id="17" name="Text 14"/>
+          <p:cNvSpPr txBox="1"/>
+          <p:nvPr/>
+        </p:nvSpPr>
+        <p:spPr>
+          <a:xfrm>
+            <a:off x="9631375" y="3358566"/>
             <a:ext cx="228600" cy="228600"/>
           </a:xfrm>
           <a:prstGeom prst="ellipse">
@@ -4940,14 +4914,14 @@
       </p:sp>
       <p:sp>
         <p:nvSpPr>
-          <p:cNvPr id="13" name="Text 10"/>
-          <p:cNvSpPr txBox="1"/>
-          <p:nvPr/>
-        </p:nvSpPr>
-        <p:spPr>
-          <a:xfrm>
-            <a:off x="832104" y="3300737"/>
-            <a:ext cx="1728216" cy="961726"/>
+          <p:cNvPr id="18" name="Text 15"/>
+          <p:cNvSpPr txBox="1"/>
+          <p:nvPr/>
+        </p:nvSpPr>
+        <p:spPr>
+          <a:xfrm>
+            <a:off x="9960559" y="3363138"/>
+            <a:ext cx="1728216" cy="1024128"/>
           </a:xfrm>
           <a:prstGeom prst="rect">
             <a:avLst/>
@@ -4974,7 +4948,7 @@
                 <a:ea typeface="Calibri" pitchFamily="34" charset="-122"/>
                 <a:cs typeface="Calibri" pitchFamily="34" charset="-120"/>
               </a:rPr>
-              <a:t>One dot, one tree</a:t>
+              <a:t>Bir nöqtə, bir ağac</a:t>
             </a:r>
             <a:endParaRPr lang="en-US" sz="1300" dirty="0"/>
           </a:p>
@@ -4991,7 +4965,7 @@
                 <a:ea typeface="Calibri" pitchFamily="34" charset="-122"/>
                 <a:cs typeface="Calibri" pitchFamily="34" charset="-120"/>
               </a:rPr>
-              <a:t>Zoom in to a farm. The colour of a dot is its variety.</a:t>
+              <a:t>Təsərrüfata yaxınlaşın. Nöqtənin rəngi sortu göstərir.</a:t>
             </a:r>
             <a:endParaRPr lang="en-US" sz="1300" dirty="0"/>
           </a:p>
@@ -4999,748 +4973,7 @@
       </p:sp>
       <p:sp>
         <p:nvSpPr>
-          <p:cNvPr id="14" name="Text 11"/>
-          <p:cNvSpPr txBox="1"/>
-          <p:nvPr/>
-        </p:nvSpPr>
-        <p:spPr>
-          <a:xfrm>
-            <a:off x="502920" y="4331043"/>
-            <a:ext cx="228600" cy="228600"/>
-          </a:xfrm>
-          <a:prstGeom prst="ellipse">
-            <a:avLst/>
-          </a:prstGeom>
-          <a:solidFill>
-            <a:srgbClr val="114230"/>
-          </a:solidFill>
-          <a:ln w="15875">
-            <a:solidFill>
-              <a:srgbClr val="FFFFFF"/>
-            </a:solidFill>
-          </a:ln>
-        </p:spPr>
-        <p:txBody>
-          <a:bodyPr wrap="square" lIns="0" tIns="0" rIns="0" bIns="0" rtlCol="0" anchor="ctr"/>
-          <a:lstStyle/>
-          <a:p>
-            <a:pPr algn="ctr" indent="0" marL="0">
-              <a:buNone/>
-            </a:pPr>
-            <a:r>
-              <a:rPr lang="en-US" sz="1000" b="1" dirty="0">
-                <a:solidFill>
-                  <a:srgbClr val="FFFFFF"/>
-                </a:solidFill>
-                <a:latin typeface="Calibri" pitchFamily="34" charset="0"/>
-                <a:ea typeface="Calibri" pitchFamily="34" charset="-122"/>
-                <a:cs typeface="Calibri" pitchFamily="34" charset="-120"/>
-              </a:rPr>
-              <a:t>3</a:t>
-            </a:r>
-            <a:endParaRPr lang="en-US" sz="1000" dirty="0"/>
-          </a:p>
-        </p:txBody>
-      </p:sp>
-      <p:sp>
-        <p:nvSpPr>
-          <p:cNvPr id="15" name="Text 12"/>
-          <p:cNvSpPr txBox="1"/>
-          <p:nvPr/>
-        </p:nvSpPr>
-        <p:spPr>
-          <a:xfrm>
-            <a:off x="832104" y="4335615"/>
-            <a:ext cx="1728216" cy="961726"/>
-          </a:xfrm>
-          <a:prstGeom prst="rect">
-            <a:avLst/>
-          </a:prstGeom>
-          <a:noFill/>
-          <a:ln/>
-        </p:spPr>
-        <p:txBody>
-          <a:bodyPr wrap="square" lIns="0" tIns="0" rIns="0" bIns="0" rtlCol="0" anchor="t"/>
-          <a:lstStyle/>
-          <a:p>
-            <a:pPr indent="0" marL="0">
-              <a:spcAft>
-                <a:spcPts val="200"/>
-              </a:spcAft>
-              <a:buNone/>
-            </a:pPr>
-            <a:r>
-              <a:rPr lang="en-US" sz="1300" b="1" dirty="0">
-                <a:solidFill>
-                  <a:srgbClr val="0D1411"/>
-                </a:solidFill>
-                <a:latin typeface="Calibri" pitchFamily="34" charset="0"/>
-                <a:ea typeface="Calibri" pitchFamily="34" charset="-122"/>
-                <a:cs typeface="Calibri" pitchFamily="34" charset="-120"/>
-              </a:rPr>
-              <a:t>Which variety</a:t>
-            </a:r>
-            <a:endParaRPr lang="en-US" sz="1300" dirty="0"/>
-          </a:p>
-          <a:p>
-            <a:pPr indent="0" marL="0">
-              <a:buNone/>
-            </a:pPr>
-            <a:r>
-              <a:rPr lang="en-US" sz="1150" dirty="0">
-                <a:solidFill>
-                  <a:srgbClr val="4A5852"/>
-                </a:solidFill>
-                <a:latin typeface="Calibri" pitchFamily="34" charset="0"/>
-                <a:ea typeface="Calibri" pitchFamily="34" charset="-122"/>
-                <a:cs typeface="Calibri" pitchFamily="34" charset="-120"/>
-              </a:rPr>
-              <a:t>Each colour is one variety of palm or fruit tree.</a:t>
-            </a:r>
-            <a:endParaRPr lang="en-US" sz="1300" dirty="0"/>
-          </a:p>
-        </p:txBody>
-      </p:sp>
-      <p:sp>
-        <p:nvSpPr>
-          <p:cNvPr id="16" name="Text 13"/>
-          <p:cNvSpPr txBox="1"/>
-          <p:nvPr/>
-        </p:nvSpPr>
-        <p:spPr>
-          <a:xfrm>
-            <a:off x="502920" y="5365922"/>
-            <a:ext cx="228600" cy="228600"/>
-          </a:xfrm>
-          <a:prstGeom prst="ellipse">
-            <a:avLst/>
-          </a:prstGeom>
-          <a:solidFill>
-            <a:srgbClr val="114230"/>
-          </a:solidFill>
-          <a:ln w="15875">
-            <a:solidFill>
-              <a:srgbClr val="FFFFFF"/>
-            </a:solidFill>
-          </a:ln>
-        </p:spPr>
-        <p:txBody>
-          <a:bodyPr wrap="square" lIns="0" tIns="0" rIns="0" bIns="0" rtlCol="0" anchor="ctr"/>
-          <a:lstStyle/>
-          <a:p>
-            <a:pPr algn="ctr" indent="0" marL="0">
-              <a:buNone/>
-            </a:pPr>
-            <a:r>
-              <a:rPr lang="en-US" sz="1000" b="1" dirty="0">
-                <a:solidFill>
-                  <a:srgbClr val="FFFFFF"/>
-                </a:solidFill>
-                <a:latin typeface="Calibri" pitchFamily="34" charset="0"/>
-                <a:ea typeface="Calibri" pitchFamily="34" charset="-122"/>
-                <a:cs typeface="Calibri" pitchFamily="34" charset="-120"/>
-              </a:rPr>
-              <a:t>4</a:t>
-            </a:r>
-            <a:endParaRPr lang="en-US" sz="1000" dirty="0"/>
-          </a:p>
-        </p:txBody>
-      </p:sp>
-      <p:sp>
-        <p:nvSpPr>
-          <p:cNvPr id="17" name="Text 14"/>
-          <p:cNvSpPr txBox="1"/>
-          <p:nvPr/>
-        </p:nvSpPr>
-        <p:spPr>
-          <a:xfrm>
-            <a:off x="832104" y="5370494"/>
-            <a:ext cx="1728216" cy="961726"/>
-          </a:xfrm>
-          <a:prstGeom prst="rect">
-            <a:avLst/>
-          </a:prstGeom>
-          <a:noFill/>
-          <a:ln/>
-        </p:spPr>
-        <p:txBody>
-          <a:bodyPr wrap="square" lIns="0" tIns="0" rIns="0" bIns="0" rtlCol="0" anchor="t"/>
-          <a:lstStyle/>
-          <a:p>
-            <a:pPr indent="0" marL="0">
-              <a:spcAft>
-                <a:spcPts val="200"/>
-              </a:spcAft>
-              <a:buNone/>
-            </a:pPr>
-            <a:r>
-              <a:rPr lang="en-US" sz="1300" b="1" dirty="0">
-                <a:solidFill>
-                  <a:srgbClr val="0D1411"/>
-                </a:solidFill>
-                <a:latin typeface="Calibri" pitchFamily="34" charset="0"/>
-                <a:ea typeface="Calibri" pitchFamily="34" charset="-122"/>
-                <a:cs typeface="Calibri" pitchFamily="34" charset="-120"/>
-              </a:rPr>
-              <a:t>Land under trees</a:t>
-            </a:r>
-            <a:endParaRPr lang="en-US" sz="1300" dirty="0"/>
-          </a:p>
-          <a:p>
-            <a:pPr indent="0" marL="0">
-              <a:buNone/>
-            </a:pPr>
-            <a:r>
-              <a:rPr lang="en-US" sz="1150" dirty="0">
-                <a:solidFill>
-                  <a:srgbClr val="4A5852"/>
-                </a:solidFill>
-                <a:latin typeface="Calibri" pitchFamily="34" charset="0"/>
-                <a:ea typeface="Calibri" pitchFamily="34" charset="-122"/>
-                <a:cs typeface="Calibri" pitchFamily="34" charset="-120"/>
-              </a:rPr>
-              <a:t>Dunums of palms, fruit trees and forest trees.</a:t>
-            </a:r>
-            <a:endParaRPr lang="en-US" sz="1300" dirty="0"/>
-          </a:p>
-        </p:txBody>
-      </p:sp>
-      <p:sp>
-        <p:nvSpPr>
-          <p:cNvPr id="18" name="Text 15"/>
-          <p:cNvSpPr txBox="1"/>
-          <p:nvPr/>
-        </p:nvSpPr>
-        <p:spPr>
-          <a:xfrm>
-            <a:off x="6278728" y="457200"/>
-            <a:ext cx="5410048" cy="237744"/>
-          </a:xfrm>
-          <a:prstGeom prst="rect">
-            <a:avLst/>
-          </a:prstGeom>
-          <a:noFill/>
-          <a:ln/>
-        </p:spPr>
-        <p:txBody>
-          <a:bodyPr wrap="square" lIns="0" tIns="0" rIns="0" bIns="0" rtlCol="0" anchor="ctr"/>
-          <a:lstStyle/>
-          <a:p>
-            <a:pPr indent="0" marL="0">
-              <a:buNone/>
-            </a:pPr>
-            <a:r>
-              <a:rPr lang="en-US" sz="1000" b="1" spc="200" kern="0" dirty="0">
-                <a:solidFill>
-                  <a:srgbClr val="1B7350"/>
-                </a:solidFill>
-                <a:latin typeface="Calibri" pitchFamily="34" charset="0"/>
-                <a:ea typeface="Calibri" pitchFamily="34" charset="-122"/>
-                <a:cs typeface="Calibri" pitchFamily="34" charset="-120"/>
-              </a:rPr>
-              <a:t>AZƏRBAYCANCA</a:t>
-            </a:r>
-            <a:endParaRPr lang="en-US" sz="1000" dirty="0"/>
-          </a:p>
-        </p:txBody>
-      </p:sp>
-      <p:sp>
-        <p:nvSpPr>
-          <p:cNvPr id="19" name="Text 16"/>
-          <p:cNvSpPr txBox="1"/>
-          <p:nvPr/>
-        </p:nvSpPr>
-        <p:spPr>
-          <a:xfrm>
-            <a:off x="6278728" y="731520"/>
-            <a:ext cx="5410048" cy="457200"/>
-          </a:xfrm>
-          <a:prstGeom prst="rect">
-            <a:avLst/>
-          </a:prstGeom>
-          <a:noFill/>
-          <a:ln/>
-        </p:spPr>
-        <p:txBody>
-          <a:bodyPr wrap="square" lIns="0" tIns="0" rIns="0" bIns="0" rtlCol="0" anchor="t"/>
-          <a:lstStyle/>
-          <a:p>
-            <a:pPr indent="0" marL="0">
-              <a:buNone/>
-            </a:pPr>
-            <a:r>
-              <a:rPr lang="en-US" sz="2400" b="1" dirty="0">
-                <a:solidFill>
-                  <a:srgbClr val="0D1411"/>
-                </a:solidFill>
-                <a:latin typeface="Calibri" pitchFamily="34" charset="0"/>
-                <a:ea typeface="Calibri" pitchFamily="34" charset="-122"/>
-                <a:cs typeface="Calibri" pitchFamily="34" charset="-120"/>
-              </a:rPr>
-              <a:t>Hər bağda hər ağac</a:t>
-            </a:r>
-            <a:endParaRPr lang="en-US" sz="2400" dirty="0"/>
-          </a:p>
-        </p:txBody>
-      </p:sp>
-      <p:sp>
-        <p:nvSpPr>
-          <p:cNvPr id="20" name="Text 17"/>
-          <p:cNvSpPr txBox="1"/>
-          <p:nvPr/>
-        </p:nvSpPr>
-        <p:spPr>
-          <a:xfrm>
-            <a:off x="6278728" y="1225296"/>
-            <a:ext cx="5410048" cy="585216"/>
-          </a:xfrm>
-          <a:prstGeom prst="rect">
-            <a:avLst/>
-          </a:prstGeom>
-          <a:noFill/>
-          <a:ln/>
-        </p:spPr>
-        <p:txBody>
-          <a:bodyPr wrap="square" lIns="0" tIns="0" rIns="0" bIns="0" rtlCol="0" anchor="t"/>
-          <a:lstStyle/>
-          <a:p>
-            <a:pPr indent="0" marL="0">
-              <a:buNone/>
-            </a:pPr>
-            <a:r>
-              <a:rPr lang="en-US" sz="1400" dirty="0">
-                <a:solidFill>
-                  <a:srgbClr val="4A5852"/>
-                </a:solidFill>
-                <a:latin typeface="Calibri" pitchFamily="34" charset="0"/>
-                <a:ea typeface="Calibri" pitchFamily="34" charset="-122"/>
-                <a:cs typeface="Calibri" pitchFamily="34" charset="-120"/>
-              </a:rPr>
-              <a:t>Peyk hər ağacı tapır, sayır və onun növünü deyir.</a:t>
-            </a:r>
-            <a:endParaRPr lang="en-US" sz="1400" dirty="0"/>
-          </a:p>
-        </p:txBody>
-      </p:sp>
-      <p:sp>
-        <p:nvSpPr>
-          <p:cNvPr id="21" name="Text 18"/>
-          <p:cNvSpPr txBox="1"/>
-          <p:nvPr/>
-        </p:nvSpPr>
-        <p:spPr>
-          <a:xfrm>
-            <a:off x="9631375" y="2261286"/>
-            <a:ext cx="228600" cy="228600"/>
-          </a:xfrm>
-          <a:prstGeom prst="ellipse">
-            <a:avLst/>
-          </a:prstGeom>
-          <a:solidFill>
-            <a:srgbClr val="114230"/>
-          </a:solidFill>
-          <a:ln w="15875">
-            <a:solidFill>
-              <a:srgbClr val="FFFFFF"/>
-            </a:solidFill>
-          </a:ln>
-        </p:spPr>
-        <p:txBody>
-          <a:bodyPr wrap="square" lIns="0" tIns="0" rIns="0" bIns="0" rtlCol="0" anchor="ctr"/>
-          <a:lstStyle/>
-          <a:p>
-            <a:pPr algn="ctr" indent="0" marL="0">
-              <a:buNone/>
-            </a:pPr>
-            <a:r>
-              <a:rPr lang="en-US" sz="1000" b="1" dirty="0">
-                <a:solidFill>
-                  <a:srgbClr val="FFFFFF"/>
-                </a:solidFill>
-                <a:latin typeface="Calibri" pitchFamily="34" charset="0"/>
-                <a:ea typeface="Calibri" pitchFamily="34" charset="-122"/>
-                <a:cs typeface="Calibri" pitchFamily="34" charset="-120"/>
-              </a:rPr>
-              <a:t>1</a:t>
-            </a:r>
-            <a:endParaRPr lang="en-US" sz="1000" dirty="0"/>
-          </a:p>
-        </p:txBody>
-      </p:sp>
-      <p:sp>
-        <p:nvSpPr>
-          <p:cNvPr id="22" name="Text 19"/>
-          <p:cNvSpPr txBox="1"/>
-          <p:nvPr/>
-        </p:nvSpPr>
-        <p:spPr>
-          <a:xfrm>
-            <a:off x="9960559" y="2265858"/>
-            <a:ext cx="1728216" cy="961726"/>
-          </a:xfrm>
-          <a:prstGeom prst="rect">
-            <a:avLst/>
-          </a:prstGeom>
-          <a:noFill/>
-          <a:ln/>
-        </p:spPr>
-        <p:txBody>
-          <a:bodyPr wrap="square" lIns="0" tIns="0" rIns="0" bIns="0" rtlCol="0" anchor="t"/>
-          <a:lstStyle/>
-          <a:p>
-            <a:pPr indent="0" marL="0">
-              <a:spcAft>
-                <a:spcPts val="200"/>
-              </a:spcAft>
-              <a:buNone/>
-            </a:pPr>
-            <a:r>
-              <a:rPr lang="en-US" sz="1300" b="1" dirty="0">
-                <a:solidFill>
-                  <a:srgbClr val="0D1411"/>
-                </a:solidFill>
-                <a:latin typeface="Calibri" pitchFamily="34" charset="0"/>
-                <a:ea typeface="Calibri" pitchFamily="34" charset="-122"/>
-                <a:cs typeface="Calibri" pitchFamily="34" charset="-120"/>
-              </a:rPr>
-              <a:t>Bütün ağaclar sayılır</a:t>
-            </a:r>
-            <a:endParaRPr lang="en-US" sz="1300" dirty="0"/>
-          </a:p>
-          <a:p>
-            <a:pPr indent="0" marL="0">
-              <a:buNone/>
-            </a:pPr>
-            <a:r>
-              <a:rPr lang="en-US" sz="1150" dirty="0">
-                <a:solidFill>
-                  <a:srgbClr val="4A5852"/>
-                </a:solidFill>
-                <a:latin typeface="Calibri" pitchFamily="34" charset="0"/>
-                <a:ea typeface="Calibri" pitchFamily="34" charset="-122"/>
-                <a:cs typeface="Calibri" pitchFamily="34" charset="-120"/>
-              </a:rPr>
-              <a:t>Xurma palmaları, meyvə və meşə ağacları.</a:t>
-            </a:r>
-            <a:endParaRPr lang="en-US" sz="1300" dirty="0"/>
-          </a:p>
-        </p:txBody>
-      </p:sp>
-      <p:sp>
-        <p:nvSpPr>
-          <p:cNvPr id="23" name="Text 20"/>
-          <p:cNvSpPr txBox="1"/>
-          <p:nvPr/>
-        </p:nvSpPr>
-        <p:spPr>
-          <a:xfrm>
-            <a:off x="9631375" y="3296165"/>
-            <a:ext cx="228600" cy="228600"/>
-          </a:xfrm>
-          <a:prstGeom prst="ellipse">
-            <a:avLst/>
-          </a:prstGeom>
-          <a:solidFill>
-            <a:srgbClr val="114230"/>
-          </a:solidFill>
-          <a:ln w="15875">
-            <a:solidFill>
-              <a:srgbClr val="FFFFFF"/>
-            </a:solidFill>
-          </a:ln>
-        </p:spPr>
-        <p:txBody>
-          <a:bodyPr wrap="square" lIns="0" tIns="0" rIns="0" bIns="0" rtlCol="0" anchor="ctr"/>
-          <a:lstStyle/>
-          <a:p>
-            <a:pPr algn="ctr" indent="0" marL="0">
-              <a:buNone/>
-            </a:pPr>
-            <a:r>
-              <a:rPr lang="en-US" sz="1000" b="1" dirty="0">
-                <a:solidFill>
-                  <a:srgbClr val="FFFFFF"/>
-                </a:solidFill>
-                <a:latin typeface="Calibri" pitchFamily="34" charset="0"/>
-                <a:ea typeface="Calibri" pitchFamily="34" charset="-122"/>
-                <a:cs typeface="Calibri" pitchFamily="34" charset="-120"/>
-              </a:rPr>
-              <a:t>2</a:t>
-            </a:r>
-            <a:endParaRPr lang="en-US" sz="1000" dirty="0"/>
-          </a:p>
-        </p:txBody>
-      </p:sp>
-      <p:sp>
-        <p:nvSpPr>
-          <p:cNvPr id="24" name="Text 21"/>
-          <p:cNvSpPr txBox="1"/>
-          <p:nvPr/>
-        </p:nvSpPr>
-        <p:spPr>
-          <a:xfrm>
-            <a:off x="9960559" y="3300737"/>
-            <a:ext cx="1728216" cy="961726"/>
-          </a:xfrm>
-          <a:prstGeom prst="rect">
-            <a:avLst/>
-          </a:prstGeom>
-          <a:noFill/>
-          <a:ln/>
-        </p:spPr>
-        <p:txBody>
-          <a:bodyPr wrap="square" lIns="0" tIns="0" rIns="0" bIns="0" rtlCol="0" anchor="t"/>
-          <a:lstStyle/>
-          <a:p>
-            <a:pPr indent="0" marL="0">
-              <a:spcAft>
-                <a:spcPts val="200"/>
-              </a:spcAft>
-              <a:buNone/>
-            </a:pPr>
-            <a:r>
-              <a:rPr lang="en-US" sz="1300" b="1" dirty="0">
-                <a:solidFill>
-                  <a:srgbClr val="0D1411"/>
-                </a:solidFill>
-                <a:latin typeface="Calibri" pitchFamily="34" charset="0"/>
-                <a:ea typeface="Calibri" pitchFamily="34" charset="-122"/>
-                <a:cs typeface="Calibri" pitchFamily="34" charset="-120"/>
-              </a:rPr>
-              <a:t>Bir nöqtə, bir ağac</a:t>
-            </a:r>
-            <a:endParaRPr lang="en-US" sz="1300" dirty="0"/>
-          </a:p>
-          <a:p>
-            <a:pPr indent="0" marL="0">
-              <a:buNone/>
-            </a:pPr>
-            <a:r>
-              <a:rPr lang="en-US" sz="1150" dirty="0">
-                <a:solidFill>
-                  <a:srgbClr val="4A5852"/>
-                </a:solidFill>
-                <a:latin typeface="Calibri" pitchFamily="34" charset="0"/>
-                <a:ea typeface="Calibri" pitchFamily="34" charset="-122"/>
-                <a:cs typeface="Calibri" pitchFamily="34" charset="-120"/>
-              </a:rPr>
-              <a:t>Təsərrüfata yaxınlaşın. Nöqtənin rəngi sortu göstərir.</a:t>
-            </a:r>
-            <a:endParaRPr lang="en-US" sz="1300" dirty="0"/>
-          </a:p>
-        </p:txBody>
-      </p:sp>
-      <p:sp>
-        <p:nvSpPr>
-          <p:cNvPr id="25" name="Text 22"/>
-          <p:cNvSpPr txBox="1"/>
-          <p:nvPr/>
-        </p:nvSpPr>
-        <p:spPr>
-          <a:xfrm>
-            <a:off x="9631375" y="4331043"/>
-            <a:ext cx="228600" cy="228600"/>
-          </a:xfrm>
-          <a:prstGeom prst="ellipse">
-            <a:avLst/>
-          </a:prstGeom>
-          <a:solidFill>
-            <a:srgbClr val="114230"/>
-          </a:solidFill>
-          <a:ln w="15875">
-            <a:solidFill>
-              <a:srgbClr val="FFFFFF"/>
-            </a:solidFill>
-          </a:ln>
-        </p:spPr>
-        <p:txBody>
-          <a:bodyPr wrap="square" lIns="0" tIns="0" rIns="0" bIns="0" rtlCol="0" anchor="ctr"/>
-          <a:lstStyle/>
-          <a:p>
-            <a:pPr algn="ctr" indent="0" marL="0">
-              <a:buNone/>
-            </a:pPr>
-            <a:r>
-              <a:rPr lang="en-US" sz="1000" b="1" dirty="0">
-                <a:solidFill>
-                  <a:srgbClr val="FFFFFF"/>
-                </a:solidFill>
-                <a:latin typeface="Calibri" pitchFamily="34" charset="0"/>
-                <a:ea typeface="Calibri" pitchFamily="34" charset="-122"/>
-                <a:cs typeface="Calibri" pitchFamily="34" charset="-120"/>
-              </a:rPr>
-              <a:t>3</a:t>
-            </a:r>
-            <a:endParaRPr lang="en-US" sz="1000" dirty="0"/>
-          </a:p>
-        </p:txBody>
-      </p:sp>
-      <p:sp>
-        <p:nvSpPr>
-          <p:cNvPr id="26" name="Text 23"/>
-          <p:cNvSpPr txBox="1"/>
-          <p:nvPr/>
-        </p:nvSpPr>
-        <p:spPr>
-          <a:xfrm>
-            <a:off x="9960559" y="4335615"/>
-            <a:ext cx="1728216" cy="961726"/>
-          </a:xfrm>
-          <a:prstGeom prst="rect">
-            <a:avLst/>
-          </a:prstGeom>
-          <a:noFill/>
-          <a:ln/>
-        </p:spPr>
-        <p:txBody>
-          <a:bodyPr wrap="square" lIns="0" tIns="0" rIns="0" bIns="0" rtlCol="0" anchor="t"/>
-          <a:lstStyle/>
-          <a:p>
-            <a:pPr indent="0" marL="0">
-              <a:spcAft>
-                <a:spcPts val="200"/>
-              </a:spcAft>
-              <a:buNone/>
-            </a:pPr>
-            <a:r>
-              <a:rPr lang="en-US" sz="1300" b="1" dirty="0">
-                <a:solidFill>
-                  <a:srgbClr val="0D1411"/>
-                </a:solidFill>
-                <a:latin typeface="Calibri" pitchFamily="34" charset="0"/>
-                <a:ea typeface="Calibri" pitchFamily="34" charset="-122"/>
-                <a:cs typeface="Calibri" pitchFamily="34" charset="-120"/>
-              </a:rPr>
-              <a:t>Hansı sort</a:t>
-            </a:r>
-            <a:endParaRPr lang="en-US" sz="1300" dirty="0"/>
-          </a:p>
-          <a:p>
-            <a:pPr indent="0" marL="0">
-              <a:buNone/>
-            </a:pPr>
-            <a:r>
-              <a:rPr lang="en-US" sz="1150" dirty="0">
-                <a:solidFill>
-                  <a:srgbClr val="4A5852"/>
-                </a:solidFill>
-                <a:latin typeface="Calibri" pitchFamily="34" charset="0"/>
-                <a:ea typeface="Calibri" pitchFamily="34" charset="-122"/>
-                <a:cs typeface="Calibri" pitchFamily="34" charset="-120"/>
-              </a:rPr>
-              <a:t>Hər rəng bir xurma və ya meyvə ağacı sortudur.</a:t>
-            </a:r>
-            <a:endParaRPr lang="en-US" sz="1300" dirty="0"/>
-          </a:p>
-        </p:txBody>
-      </p:sp>
-      <p:sp>
-        <p:nvSpPr>
-          <p:cNvPr id="27" name="Text 24"/>
-          <p:cNvSpPr txBox="1"/>
-          <p:nvPr/>
-        </p:nvSpPr>
-        <p:spPr>
-          <a:xfrm>
-            <a:off x="9631375" y="5365922"/>
-            <a:ext cx="228600" cy="228600"/>
-          </a:xfrm>
-          <a:prstGeom prst="ellipse">
-            <a:avLst/>
-          </a:prstGeom>
-          <a:solidFill>
-            <a:srgbClr val="114230"/>
-          </a:solidFill>
-          <a:ln w="15875">
-            <a:solidFill>
-              <a:srgbClr val="FFFFFF"/>
-            </a:solidFill>
-          </a:ln>
-        </p:spPr>
-        <p:txBody>
-          <a:bodyPr wrap="square" lIns="0" tIns="0" rIns="0" bIns="0" rtlCol="0" anchor="ctr"/>
-          <a:lstStyle/>
-          <a:p>
-            <a:pPr algn="ctr" indent="0" marL="0">
-              <a:buNone/>
-            </a:pPr>
-            <a:r>
-              <a:rPr lang="en-US" sz="1000" b="1" dirty="0">
-                <a:solidFill>
-                  <a:srgbClr val="FFFFFF"/>
-                </a:solidFill>
-                <a:latin typeface="Calibri" pitchFamily="34" charset="0"/>
-                <a:ea typeface="Calibri" pitchFamily="34" charset="-122"/>
-                <a:cs typeface="Calibri" pitchFamily="34" charset="-120"/>
-              </a:rPr>
-              <a:t>4</a:t>
-            </a:r>
-            <a:endParaRPr lang="en-US" sz="1000" dirty="0"/>
-          </a:p>
-        </p:txBody>
-      </p:sp>
-      <p:sp>
-        <p:nvSpPr>
-          <p:cNvPr id="28" name="Text 25"/>
-          <p:cNvSpPr txBox="1"/>
-          <p:nvPr/>
-        </p:nvSpPr>
-        <p:spPr>
-          <a:xfrm>
-            <a:off x="9960559" y="5370494"/>
-            <a:ext cx="1728216" cy="961726"/>
-          </a:xfrm>
-          <a:prstGeom prst="rect">
-            <a:avLst/>
-          </a:prstGeom>
-          <a:noFill/>
-          <a:ln/>
-        </p:spPr>
-        <p:txBody>
-          <a:bodyPr wrap="square" lIns="0" tIns="0" rIns="0" bIns="0" rtlCol="0" anchor="t"/>
-          <a:lstStyle/>
-          <a:p>
-            <a:pPr indent="0" marL="0">
-              <a:spcAft>
-                <a:spcPts val="200"/>
-              </a:spcAft>
-              <a:buNone/>
-            </a:pPr>
-            <a:r>
-              <a:rPr lang="en-US" sz="1300" b="1" dirty="0">
-                <a:solidFill>
-                  <a:srgbClr val="0D1411"/>
-                </a:solidFill>
-                <a:latin typeface="Calibri" pitchFamily="34" charset="0"/>
-                <a:ea typeface="Calibri" pitchFamily="34" charset="-122"/>
-                <a:cs typeface="Calibri" pitchFamily="34" charset="-120"/>
-              </a:rPr>
-              <a:t>Ağacların torpağı</a:t>
-            </a:r>
-            <a:endParaRPr lang="en-US" sz="1300" dirty="0"/>
-          </a:p>
-          <a:p>
-            <a:pPr indent="0" marL="0">
-              <a:buNone/>
-            </a:pPr>
-            <a:r>
-              <a:rPr lang="en-US" sz="1150" dirty="0">
-                <a:solidFill>
-                  <a:srgbClr val="4A5852"/>
-                </a:solidFill>
-                <a:latin typeface="Calibri" pitchFamily="34" charset="0"/>
-                <a:ea typeface="Calibri" pitchFamily="34" charset="-122"/>
-                <a:cs typeface="Calibri" pitchFamily="34" charset="-120"/>
-              </a:rPr>
-              <a:t>Xurma, meyvə və meşə ağaclarının dönümü.</a:t>
-            </a:r>
-            <a:endParaRPr lang="en-US" sz="1300" dirty="0"/>
-          </a:p>
-        </p:txBody>
-      </p:sp>
-      <p:sp>
-        <p:nvSpPr>
-          <p:cNvPr id="30" name="Text 26"/>
+          <p:cNvPr id="20" name="Text 16"/>
           <p:cNvSpPr txBox="1"/>
           <p:nvPr/>
         </p:nvSpPr>
@@ -6228,7 +5461,7 @@
                 <a:ea typeface="Calibri" pitchFamily="34" charset="-122"/>
                 <a:cs typeface="Calibri" pitchFamily="34" charset="-120"/>
               </a:rPr>
-              <a:t>For palms and fruit trees. 80 or more is healthy.</a:t>
+              <a:t>For crops and fruit trees.</a:t>
             </a:r>
             <a:endParaRPr lang="en-US" sz="1300" dirty="0"/>
           </a:p>
@@ -6332,7 +5565,7 @@
                 <a:ea typeface="Calibri" pitchFamily="34" charset="-122"/>
                 <a:cs typeface="Calibri" pitchFamily="34" charset="-120"/>
               </a:rPr>
-              <a:t>Here: 6 farms have very stressed trees.</a:t>
+              <a:t>Here: 6 farms have very stressed crops.</a:t>
             </a:r>
             <a:endParaRPr lang="en-US" sz="1300" dirty="0"/>
           </a:p>
@@ -6761,7 +5994,7 @@
                 <a:ea typeface="Calibri" pitchFamily="34" charset="-122"/>
                 <a:cs typeface="Calibri" pitchFamily="34" charset="-120"/>
               </a:rPr>
-              <a:t>Xurma və meyvə ağacları üçün. 80 və yuxarı sağlamdır.</a:t>
+              <a:t>Əkinlər və meyvə ağacları üçün.</a:t>
             </a:r>
             <a:endParaRPr lang="en-US" sz="1300" dirty="0"/>
           </a:p>
@@ -6865,7 +6098,7 @@
                 <a:ea typeface="Calibri" pitchFamily="34" charset="-122"/>
                 <a:cs typeface="Calibri" pitchFamily="34" charset="-120"/>
               </a:rPr>
-              <a:t>Burada: 6 təsərrüfatda ağaclar çox zəifdir.</a:t>
+              <a:t>Burada: 6 təsərrüfatda əkinlər çox zəifdir.</a:t>
             </a:r>
             <a:endParaRPr lang="en-US" sz="1300" dirty="0"/>
           </a:p>
@@ -8658,7 +7891,124 @@
         </p:nvSpPr>
         <p:spPr>
           <a:xfrm>
-            <a:off x="3369353" y="4345526"/>
+            <a:off x="502920" y="457200"/>
+            <a:ext cx="5410048" cy="237744"/>
+          </a:xfrm>
+          <a:prstGeom prst="rect">
+            <a:avLst/>
+          </a:prstGeom>
+          <a:noFill/>
+          <a:ln/>
+        </p:spPr>
+        <p:txBody>
+          <a:bodyPr wrap="square" lIns="0" tIns="0" rIns="0" bIns="0" rtlCol="0" anchor="ctr"/>
+          <a:lstStyle/>
+          <a:p>
+            <a:pPr indent="0" marL="0">
+              <a:buNone/>
+            </a:pPr>
+            <a:r>
+              <a:rPr lang="en-US" sz="1000" b="1" spc="200" kern="0" dirty="0">
+                <a:solidFill>
+                  <a:srgbClr val="1B7350"/>
+                </a:solidFill>
+                <a:latin typeface="Calibri" pitchFamily="34" charset="0"/>
+                <a:ea typeface="Calibri" pitchFamily="34" charset="-122"/>
+                <a:cs typeface="Calibri" pitchFamily="34" charset="-120"/>
+              </a:rPr>
+              <a:t>ENGLISH</a:t>
+            </a:r>
+            <a:endParaRPr lang="en-US" sz="1000" dirty="0"/>
+          </a:p>
+        </p:txBody>
+      </p:sp>
+      <p:sp>
+        <p:nvSpPr>
+          <p:cNvPr id="7" name="Text 4"/>
+          <p:cNvSpPr txBox="1"/>
+          <p:nvPr/>
+        </p:nvSpPr>
+        <p:spPr>
+          <a:xfrm>
+            <a:off x="502920" y="731520"/>
+            <a:ext cx="5410048" cy="457200"/>
+          </a:xfrm>
+          <a:prstGeom prst="rect">
+            <a:avLst/>
+          </a:prstGeom>
+          <a:noFill/>
+          <a:ln/>
+        </p:spPr>
+        <p:txBody>
+          <a:bodyPr wrap="square" lIns="0" tIns="0" rIns="0" bIns="0" rtlCol="0" anchor="t"/>
+          <a:lstStyle/>
+          <a:p>
+            <a:pPr indent="0" marL="0">
+              <a:buNone/>
+            </a:pPr>
+            <a:r>
+              <a:rPr lang="en-US" sz="2400" b="1" dirty="0">
+                <a:solidFill>
+                  <a:srgbClr val="0D1411"/>
+                </a:solidFill>
+                <a:latin typeface="Calibri" pitchFamily="34" charset="0"/>
+                <a:ea typeface="Calibri" pitchFamily="34" charset="-122"/>
+                <a:cs typeface="Calibri" pitchFamily="34" charset="-120"/>
+              </a:rPr>
+              <a:t>From a score to a farm visit</a:t>
+            </a:r>
+            <a:endParaRPr lang="en-US" sz="2400" dirty="0"/>
+          </a:p>
+        </p:txBody>
+      </p:sp>
+      <p:sp>
+        <p:nvSpPr>
+          <p:cNvPr id="8" name="Text 5"/>
+          <p:cNvSpPr txBox="1"/>
+          <p:nvPr/>
+        </p:nvSpPr>
+        <p:spPr>
+          <a:xfrm>
+            <a:off x="502920" y="1225296"/>
+            <a:ext cx="5410048" cy="585216"/>
+          </a:xfrm>
+          <a:prstGeom prst="rect">
+            <a:avLst/>
+          </a:prstGeom>
+          <a:noFill/>
+          <a:ln/>
+        </p:spPr>
+        <p:txBody>
+          <a:bodyPr wrap="square" lIns="0" tIns="0" rIns="0" bIns="0" rtlCol="0" anchor="t"/>
+          <a:lstStyle/>
+          <a:p>
+            <a:pPr indent="0" marL="0">
+              <a:buNone/>
+            </a:pPr>
+            <a:r>
+              <a:rPr lang="en-US" sz="1400" dirty="0">
+                <a:solidFill>
+                  <a:srgbClr val="4A5852"/>
+                </a:solidFill>
+                <a:latin typeface="Calibri" pitchFamily="34" charset="0"/>
+                <a:ea typeface="Calibri" pitchFamily="34" charset="-122"/>
+                <a:cs typeface="Calibri" pitchFamily="34" charset="-120"/>
+              </a:rPr>
+              <a:t>What to check on this farm. The website does not name the disease. It shows where to look.</a:t>
+            </a:r>
+            <a:endParaRPr lang="en-US" sz="1400" dirty="0"/>
+          </a:p>
+        </p:txBody>
+      </p:sp>
+      <p:sp>
+        <p:nvSpPr>
+          <p:cNvPr id="9" name="Text 6"/>
+          <p:cNvSpPr txBox="1"/>
+          <p:nvPr/>
+        </p:nvSpPr>
+        <p:spPr>
+          <a:xfrm>
+            <a:off x="502920" y="2261286"/>
             <a:ext cx="228600" cy="228600"/>
           </a:xfrm>
           <a:prstGeom prst="ellipse">
@@ -8689,7 +8039,7 @@
                 <a:ea typeface="Calibri" pitchFamily="34" charset="-122"/>
                 <a:cs typeface="Calibri" pitchFamily="34" charset="-120"/>
               </a:rPr>
-              <a:t>4</a:t>
+              <a:t>1</a:t>
             </a:r>
             <a:endParaRPr lang="en-US" sz="1000" dirty="0"/>
           </a:p>
@@ -8697,53 +8047,14 @@
       </p:sp>
       <p:sp>
         <p:nvSpPr>
-          <p:cNvPr id="7" name="Text 4"/>
-          <p:cNvSpPr txBox="1"/>
-          <p:nvPr/>
-        </p:nvSpPr>
-        <p:spPr>
-          <a:xfrm>
-            <a:off x="502920" y="457200"/>
-            <a:ext cx="5410048" cy="237744"/>
-          </a:xfrm>
-          <a:prstGeom prst="rect">
-            <a:avLst/>
-          </a:prstGeom>
-          <a:noFill/>
-          <a:ln/>
-        </p:spPr>
-        <p:txBody>
-          <a:bodyPr wrap="square" lIns="0" tIns="0" rIns="0" bIns="0" rtlCol="0" anchor="ctr"/>
-          <a:lstStyle/>
-          <a:p>
-            <a:pPr indent="0" marL="0">
-              <a:buNone/>
-            </a:pPr>
-            <a:r>
-              <a:rPr lang="en-US" sz="1000" b="1" spc="200" kern="0" dirty="0">
-                <a:solidFill>
-                  <a:srgbClr val="1B7350"/>
-                </a:solidFill>
-                <a:latin typeface="Calibri" pitchFamily="34" charset="0"/>
-                <a:ea typeface="Calibri" pitchFamily="34" charset="-122"/>
-                <a:cs typeface="Calibri" pitchFamily="34" charset="-120"/>
-              </a:rPr>
-              <a:t>ENGLISH</a:t>
-            </a:r>
-            <a:endParaRPr lang="en-US" sz="1000" dirty="0"/>
-          </a:p>
-        </p:txBody>
-      </p:sp>
-      <p:sp>
-        <p:nvSpPr>
-          <p:cNvPr id="8" name="Text 5"/>
-          <p:cNvSpPr txBox="1"/>
-          <p:nvPr/>
-        </p:nvSpPr>
-        <p:spPr>
-          <a:xfrm>
-            <a:off x="502920" y="731520"/>
-            <a:ext cx="5410048" cy="457200"/>
+          <p:cNvPr id="10" name="Text 7"/>
+          <p:cNvSpPr txBox="1"/>
+          <p:nvPr/>
+        </p:nvSpPr>
+        <p:spPr>
+          <a:xfrm>
+            <a:off x="832104" y="2265858"/>
+            <a:ext cx="1728216" cy="1024128"/>
           </a:xfrm>
           <a:prstGeom prst="rect">
             <a:avLst/>
@@ -8756,10 +8067,13 @@
           <a:lstStyle/>
           <a:p>
             <a:pPr indent="0" marL="0">
-              <a:buNone/>
-            </a:pPr>
-            <a:r>
-              <a:rPr lang="en-US" sz="2400" b="1" dirty="0">
+              <a:spcAft>
+                <a:spcPts val="200"/>
+              </a:spcAft>
+              <a:buNone/>
+            </a:pPr>
+            <a:r>
+              <a:rPr lang="en-US" sz="1300" b="1" dirty="0">
                 <a:solidFill>
                   <a:srgbClr val="0D1411"/>
                 </a:solidFill>
@@ -8767,38 +8081,16 @@
                 <a:ea typeface="Calibri" pitchFamily="34" charset="-122"/>
                 <a:cs typeface="Calibri" pitchFamily="34" charset="-120"/>
               </a:rPr>
-              <a:t>From a score to a farm visit</a:t>
-            </a:r>
-            <a:endParaRPr lang="en-US" sz="2400" dirty="0"/>
-          </a:p>
-        </p:txBody>
-      </p:sp>
-      <p:sp>
-        <p:nvSpPr>
-          <p:cNvPr id="9" name="Text 6"/>
-          <p:cNvSpPr txBox="1"/>
-          <p:nvPr/>
-        </p:nvSpPr>
-        <p:spPr>
-          <a:xfrm>
-            <a:off x="502920" y="1225296"/>
-            <a:ext cx="5410048" cy="585216"/>
-          </a:xfrm>
-          <a:prstGeom prst="rect">
-            <a:avLst/>
-          </a:prstGeom>
-          <a:noFill/>
-          <a:ln/>
-        </p:spPr>
-        <p:txBody>
-          <a:bodyPr wrap="square" lIns="0" tIns="0" rIns="0" bIns="0" rtlCol="0" anchor="t"/>
-          <a:lstStyle/>
-          <a:p>
-            <a:pPr indent="0" marL="0">
-              <a:buNone/>
-            </a:pPr>
-            <a:r>
-              <a:rPr lang="en-US" sz="1400" dirty="0">
+              <a:t>Most urgent first</a:t>
+            </a:r>
+            <a:endParaRPr lang="en-US" sz="1300" dirty="0"/>
+          </a:p>
+          <a:p>
+            <a:pPr indent="0" marL="0">
+              <a:buNone/>
+            </a:pPr>
+            <a:r>
+              <a:rPr lang="en-US" sz="1150" dirty="0">
                 <a:solidFill>
                   <a:srgbClr val="4A5852"/>
                 </a:solidFill>
@@ -8806,21 +8098,21 @@
                 <a:ea typeface="Calibri" pitchFamily="34" charset="-122"/>
                 <a:cs typeface="Calibri" pitchFamily="34" charset="-120"/>
               </a:rPr>
-              <a:t>What to check on this farm. The website does not name the disease. It shows where to look.</a:t>
-            </a:r>
-            <a:endParaRPr lang="en-US" sz="1400" dirty="0"/>
-          </a:p>
-        </p:txBody>
-      </p:sp>
-      <p:sp>
-        <p:nvSpPr>
-          <p:cNvPr id="10" name="Text 7"/>
-          <p:cNvSpPr txBox="1"/>
-          <p:nvPr/>
-        </p:nvSpPr>
-        <p:spPr>
-          <a:xfrm>
-            <a:off x="502920" y="2261286"/>
+              <a:t>Each problem, with a short reason.</a:t>
+            </a:r>
+            <a:endParaRPr lang="en-US" sz="1300" dirty="0"/>
+          </a:p>
+        </p:txBody>
+      </p:sp>
+      <p:sp>
+        <p:nvSpPr>
+          <p:cNvPr id="11" name="Text 8"/>
+          <p:cNvSpPr txBox="1"/>
+          <p:nvPr/>
+        </p:nvSpPr>
+        <p:spPr>
+          <a:xfrm>
+            <a:off x="502920" y="3358566"/>
             <a:ext cx="228600" cy="228600"/>
           </a:xfrm>
           <a:prstGeom prst="ellipse">
@@ -8851,7 +8143,7 @@
                 <a:ea typeface="Calibri" pitchFamily="34" charset="-122"/>
                 <a:cs typeface="Calibri" pitchFamily="34" charset="-120"/>
               </a:rPr>
-              <a:t>1</a:t>
+              <a:t>2</a:t>
             </a:r>
             <a:endParaRPr lang="en-US" sz="1000" dirty="0"/>
           </a:p>
@@ -8859,14 +8151,14 @@
       </p:sp>
       <p:sp>
         <p:nvSpPr>
-          <p:cNvPr id="11" name="Text 8"/>
-          <p:cNvSpPr txBox="1"/>
-          <p:nvPr/>
-        </p:nvSpPr>
-        <p:spPr>
-          <a:xfrm>
-            <a:off x="832104" y="2265858"/>
-            <a:ext cx="1728216" cy="961726"/>
+          <p:cNvPr id="12" name="Text 9"/>
+          <p:cNvSpPr txBox="1"/>
+          <p:nvPr/>
+        </p:nvSpPr>
+        <p:spPr>
+          <a:xfrm>
+            <a:off x="832104" y="3363138"/>
+            <a:ext cx="1728216" cy="1024128"/>
           </a:xfrm>
           <a:prstGeom prst="rect">
             <a:avLst/>
@@ -8893,7 +8185,7 @@
                 <a:ea typeface="Calibri" pitchFamily="34" charset="-122"/>
                 <a:cs typeface="Calibri" pitchFamily="34" charset="-120"/>
               </a:rPr>
-              <a:t>Most urgent first</a:t>
+              <a:t>What to do</a:t>
             </a:r>
             <a:endParaRPr lang="en-US" sz="1300" dirty="0"/>
           </a:p>
@@ -8910,7 +8202,7 @@
                 <a:ea typeface="Calibri" pitchFamily="34" charset="-122"/>
                 <a:cs typeface="Calibri" pitchFamily="34" charset="-120"/>
               </a:rPr>
-              <a:t>Each problem, with a short reason.</a:t>
+              <a:t>Look for lack of water, salt in the soil, or pests.</a:t>
             </a:r>
             <a:endParaRPr lang="en-US" sz="1300" dirty="0"/>
           </a:p>
@@ -8918,13 +8210,13 @@
       </p:sp>
       <p:sp>
         <p:nvSpPr>
-          <p:cNvPr id="12" name="Text 9"/>
-          <p:cNvSpPr txBox="1"/>
-          <p:nvPr/>
-        </p:nvSpPr>
-        <p:spPr>
-          <a:xfrm>
-            <a:off x="502920" y="3296165"/>
+          <p:cNvPr id="13" name="Text 10"/>
+          <p:cNvSpPr txBox="1"/>
+          <p:nvPr/>
+        </p:nvSpPr>
+        <p:spPr>
+          <a:xfrm>
+            <a:off x="502920" y="4455846"/>
             <a:ext cx="228600" cy="228600"/>
           </a:xfrm>
           <a:prstGeom prst="ellipse">
@@ -8955,7 +8247,7 @@
                 <a:ea typeface="Calibri" pitchFamily="34" charset="-122"/>
                 <a:cs typeface="Calibri" pitchFamily="34" charset="-120"/>
               </a:rPr>
-              <a:t>2</a:t>
+              <a:t>3</a:t>
             </a:r>
             <a:endParaRPr lang="en-US" sz="1000" dirty="0"/>
           </a:p>
@@ -8963,14 +8255,14 @@
       </p:sp>
       <p:sp>
         <p:nvSpPr>
-          <p:cNvPr id="13" name="Text 10"/>
-          <p:cNvSpPr txBox="1"/>
-          <p:nvPr/>
-        </p:nvSpPr>
-        <p:spPr>
-          <a:xfrm>
-            <a:off x="832104" y="3300737"/>
-            <a:ext cx="1728216" cy="961726"/>
+          <p:cNvPr id="14" name="Text 11"/>
+          <p:cNvSpPr txBox="1"/>
+          <p:nvPr/>
+        </p:nvSpPr>
+        <p:spPr>
+          <a:xfrm>
+            <a:off x="832104" y="4460418"/>
+            <a:ext cx="1728216" cy="1024128"/>
           </a:xfrm>
           <a:prstGeom prst="rect">
             <a:avLst/>
@@ -8997,7 +8289,7 @@
                 <a:ea typeface="Calibri" pitchFamily="34" charset="-122"/>
                 <a:cs typeface="Calibri" pitchFamily="34" charset="-120"/>
               </a:rPr>
-              <a:t>What to do</a:t>
+              <a:t>Take it to the farm</a:t>
             </a:r>
             <a:endParaRPr lang="en-US" sz="1300" dirty="0"/>
           </a:p>
@@ -9014,7 +8306,7 @@
                 <a:ea typeface="Calibri" pitchFamily="34" charset="-122"/>
                 <a:cs typeface="Calibri" pitchFamily="34" charset="-120"/>
               </a:rPr>
-              <a:t>Look for lack of water, salt in the soil, or pests.</a:t>
+              <a:t>Print one page for the visit.</a:t>
             </a:r>
             <a:endParaRPr lang="en-US" sz="1300" dirty="0"/>
           </a:p>
@@ -9022,13 +8314,130 @@
       </p:sp>
       <p:sp>
         <p:nvSpPr>
-          <p:cNvPr id="14" name="Text 11"/>
-          <p:cNvSpPr txBox="1"/>
-          <p:nvPr/>
-        </p:nvSpPr>
-        <p:spPr>
-          <a:xfrm>
-            <a:off x="502920" y="4331043"/>
+          <p:cNvPr id="15" name="Text 12"/>
+          <p:cNvSpPr txBox="1"/>
+          <p:nvPr/>
+        </p:nvSpPr>
+        <p:spPr>
+          <a:xfrm>
+            <a:off x="6278728" y="457200"/>
+            <a:ext cx="5410048" cy="237744"/>
+          </a:xfrm>
+          <a:prstGeom prst="rect">
+            <a:avLst/>
+          </a:prstGeom>
+          <a:noFill/>
+          <a:ln/>
+        </p:spPr>
+        <p:txBody>
+          <a:bodyPr wrap="square" lIns="0" tIns="0" rIns="0" bIns="0" rtlCol="0" anchor="ctr"/>
+          <a:lstStyle/>
+          <a:p>
+            <a:pPr indent="0" marL="0">
+              <a:buNone/>
+            </a:pPr>
+            <a:r>
+              <a:rPr lang="en-US" sz="1000" b="1" spc="200" kern="0" dirty="0">
+                <a:solidFill>
+                  <a:srgbClr val="1B7350"/>
+                </a:solidFill>
+                <a:latin typeface="Calibri" pitchFamily="34" charset="0"/>
+                <a:ea typeface="Calibri" pitchFamily="34" charset="-122"/>
+                <a:cs typeface="Calibri" pitchFamily="34" charset="-120"/>
+              </a:rPr>
+              <a:t>AZƏRBAYCANCA</a:t>
+            </a:r>
+            <a:endParaRPr lang="en-US" sz="1000" dirty="0"/>
+          </a:p>
+        </p:txBody>
+      </p:sp>
+      <p:sp>
+        <p:nvSpPr>
+          <p:cNvPr id="16" name="Text 13"/>
+          <p:cNvSpPr txBox="1"/>
+          <p:nvPr/>
+        </p:nvSpPr>
+        <p:spPr>
+          <a:xfrm>
+            <a:off x="6278728" y="731520"/>
+            <a:ext cx="5410048" cy="457200"/>
+          </a:xfrm>
+          <a:prstGeom prst="rect">
+            <a:avLst/>
+          </a:prstGeom>
+          <a:noFill/>
+          <a:ln/>
+        </p:spPr>
+        <p:txBody>
+          <a:bodyPr wrap="square" lIns="0" tIns="0" rIns="0" bIns="0" rtlCol="0" anchor="t"/>
+          <a:lstStyle/>
+          <a:p>
+            <a:pPr indent="0" marL="0">
+              <a:buNone/>
+            </a:pPr>
+            <a:r>
+              <a:rPr lang="en-US" sz="2400" b="1" dirty="0">
+                <a:solidFill>
+                  <a:srgbClr val="0D1411"/>
+                </a:solidFill>
+                <a:latin typeface="Calibri" pitchFamily="34" charset="0"/>
+                <a:ea typeface="Calibri" pitchFamily="34" charset="-122"/>
+                <a:cs typeface="Calibri" pitchFamily="34" charset="-120"/>
+              </a:rPr>
+              <a:t>Baldan təsərrüfat ziyarətinə</a:t>
+            </a:r>
+            <a:endParaRPr lang="en-US" sz="2400" dirty="0"/>
+          </a:p>
+        </p:txBody>
+      </p:sp>
+      <p:sp>
+        <p:nvSpPr>
+          <p:cNvPr id="17" name="Text 14"/>
+          <p:cNvSpPr txBox="1"/>
+          <p:nvPr/>
+        </p:nvSpPr>
+        <p:spPr>
+          <a:xfrm>
+            <a:off x="6278728" y="1225296"/>
+            <a:ext cx="5410048" cy="585216"/>
+          </a:xfrm>
+          <a:prstGeom prst="rect">
+            <a:avLst/>
+          </a:prstGeom>
+          <a:noFill/>
+          <a:ln/>
+        </p:spPr>
+        <p:txBody>
+          <a:bodyPr wrap="square" lIns="0" tIns="0" rIns="0" bIns="0" rtlCol="0" anchor="t"/>
+          <a:lstStyle/>
+          <a:p>
+            <a:pPr indent="0" marL="0">
+              <a:buNone/>
+            </a:pPr>
+            <a:r>
+              <a:rPr lang="en-US" sz="1400" dirty="0">
+                <a:solidFill>
+                  <a:srgbClr val="4A5852"/>
+                </a:solidFill>
+                <a:latin typeface="Calibri" pitchFamily="34" charset="0"/>
+                <a:ea typeface="Calibri" pitchFamily="34" charset="-122"/>
+                <a:cs typeface="Calibri" pitchFamily="34" charset="-120"/>
+              </a:rPr>
+              <a:t>Bu təsərrüfatda nəyi yoxlamaq lazımdır. Sayt xəstəliyin adını demir. Harada baxmağı göstərir.</a:t>
+            </a:r>
+            <a:endParaRPr lang="en-US" sz="1400" dirty="0"/>
+          </a:p>
+        </p:txBody>
+      </p:sp>
+      <p:sp>
+        <p:nvSpPr>
+          <p:cNvPr id="18" name="Text 15"/>
+          <p:cNvSpPr txBox="1"/>
+          <p:nvPr/>
+        </p:nvSpPr>
+        <p:spPr>
+          <a:xfrm>
+            <a:off x="9631375" y="2261286"/>
             <a:ext cx="228600" cy="228600"/>
           </a:xfrm>
           <a:prstGeom prst="ellipse">
@@ -9059,7 +8468,7 @@
                 <a:ea typeface="Calibri" pitchFamily="34" charset="-122"/>
                 <a:cs typeface="Calibri" pitchFamily="34" charset="-120"/>
               </a:rPr>
-              <a:t>3</a:t>
+              <a:t>1</a:t>
             </a:r>
             <a:endParaRPr lang="en-US" sz="1000" dirty="0"/>
           </a:p>
@@ -9067,14 +8476,14 @@
       </p:sp>
       <p:sp>
         <p:nvSpPr>
-          <p:cNvPr id="15" name="Text 12"/>
-          <p:cNvSpPr txBox="1"/>
-          <p:nvPr/>
-        </p:nvSpPr>
-        <p:spPr>
-          <a:xfrm>
-            <a:off x="832104" y="4335615"/>
-            <a:ext cx="1728216" cy="961726"/>
+          <p:cNvPr id="19" name="Text 16"/>
+          <p:cNvSpPr txBox="1"/>
+          <p:nvPr/>
+        </p:nvSpPr>
+        <p:spPr>
+          <a:xfrm>
+            <a:off x="9960559" y="2265858"/>
+            <a:ext cx="1728216" cy="1024128"/>
           </a:xfrm>
           <a:prstGeom prst="rect">
             <a:avLst/>
@@ -9101,7 +8510,7 @@
                 <a:ea typeface="Calibri" pitchFamily="34" charset="-122"/>
                 <a:cs typeface="Calibri" pitchFamily="34" charset="-120"/>
               </a:rPr>
-              <a:t>Take it to the farm</a:t>
+              <a:t>Ən təcili birinci</a:t>
             </a:r>
             <a:endParaRPr lang="en-US" sz="1300" dirty="0"/>
           </a:p>
@@ -9118,7 +8527,7 @@
                 <a:ea typeface="Calibri" pitchFamily="34" charset="-122"/>
                 <a:cs typeface="Calibri" pitchFamily="34" charset="-120"/>
               </a:rPr>
-              <a:t>Print one page for the visit.</a:t>
+              <a:t>Hər problem və qısa səbəbi.</a:t>
             </a:r>
             <a:endParaRPr lang="en-US" sz="1300" dirty="0"/>
           </a:p>
@@ -9126,13 +8535,13 @@
       </p:sp>
       <p:sp>
         <p:nvSpPr>
-          <p:cNvPr id="16" name="Text 13"/>
-          <p:cNvSpPr txBox="1"/>
-          <p:nvPr/>
-        </p:nvSpPr>
-        <p:spPr>
-          <a:xfrm>
-            <a:off x="502920" y="5365922"/>
+          <p:cNvPr id="20" name="Text 17"/>
+          <p:cNvSpPr txBox="1"/>
+          <p:nvPr/>
+        </p:nvSpPr>
+        <p:spPr>
+          <a:xfrm>
+            <a:off x="9631375" y="3358566"/>
             <a:ext cx="228600" cy="228600"/>
           </a:xfrm>
           <a:prstGeom prst="ellipse">
@@ -9163,7 +8572,7 @@
                 <a:ea typeface="Calibri" pitchFamily="34" charset="-122"/>
                 <a:cs typeface="Calibri" pitchFamily="34" charset="-120"/>
               </a:rPr>
-              <a:t>4</a:t>
+              <a:t>2</a:t>
             </a:r>
             <a:endParaRPr lang="en-US" sz="1000" dirty="0"/>
           </a:p>
@@ -9171,14 +8580,14 @@
       </p:sp>
       <p:sp>
         <p:nvSpPr>
-          <p:cNvPr id="17" name="Text 14"/>
-          <p:cNvSpPr txBox="1"/>
-          <p:nvPr/>
-        </p:nvSpPr>
-        <p:spPr>
-          <a:xfrm>
-            <a:off x="832104" y="5370494"/>
-            <a:ext cx="1728216" cy="961726"/>
+          <p:cNvPr id="21" name="Text 18"/>
+          <p:cNvSpPr txBox="1"/>
+          <p:nvPr/>
+        </p:nvSpPr>
+        <p:spPr>
+          <a:xfrm>
+            <a:off x="9960559" y="3363138"/>
+            <a:ext cx="1728216" cy="1024128"/>
           </a:xfrm>
           <a:prstGeom prst="rect">
             <a:avLst/>
@@ -9205,7 +8614,7 @@
                 <a:ea typeface="Calibri" pitchFamily="34" charset="-122"/>
                 <a:cs typeface="Calibri" pitchFamily="34" charset="-120"/>
               </a:rPr>
-              <a:t>A possible cause</a:t>
+              <a:t>Nə etməli</a:t>
             </a:r>
             <a:endParaRPr lang="en-US" sz="1300" dirty="0"/>
           </a:p>
@@ -9222,7 +8631,7 @@
                 <a:ea typeface="Calibri" pitchFamily="34" charset="-122"/>
                 <a:cs typeface="Calibri" pitchFamily="34" charset="-120"/>
               </a:rPr>
-              <a:t>The farm used only 70% of the water it is allowed.</a:t>
+              <a:t>Su çatışmazlığını, torpaqda duzu və ya zərərvericiləri axtarın.</a:t>
             </a:r>
             <a:endParaRPr lang="en-US" sz="1300" dirty="0"/>
           </a:p>
@@ -9230,130 +8639,13 @@
       </p:sp>
       <p:sp>
         <p:nvSpPr>
-          <p:cNvPr id="18" name="Text 15"/>
-          <p:cNvSpPr txBox="1"/>
-          <p:nvPr/>
-        </p:nvSpPr>
-        <p:spPr>
-          <a:xfrm>
-            <a:off x="6278728" y="457200"/>
-            <a:ext cx="5410048" cy="237744"/>
-          </a:xfrm>
-          <a:prstGeom prst="rect">
-            <a:avLst/>
-          </a:prstGeom>
-          <a:noFill/>
-          <a:ln/>
-        </p:spPr>
-        <p:txBody>
-          <a:bodyPr wrap="square" lIns="0" tIns="0" rIns="0" bIns="0" rtlCol="0" anchor="ctr"/>
-          <a:lstStyle/>
-          <a:p>
-            <a:pPr indent="0" marL="0">
-              <a:buNone/>
-            </a:pPr>
-            <a:r>
-              <a:rPr lang="en-US" sz="1000" b="1" spc="200" kern="0" dirty="0">
-                <a:solidFill>
-                  <a:srgbClr val="1B7350"/>
-                </a:solidFill>
-                <a:latin typeface="Calibri" pitchFamily="34" charset="0"/>
-                <a:ea typeface="Calibri" pitchFamily="34" charset="-122"/>
-                <a:cs typeface="Calibri" pitchFamily="34" charset="-120"/>
-              </a:rPr>
-              <a:t>AZƏRBAYCANCA</a:t>
-            </a:r>
-            <a:endParaRPr lang="en-US" sz="1000" dirty="0"/>
-          </a:p>
-        </p:txBody>
-      </p:sp>
-      <p:sp>
-        <p:nvSpPr>
-          <p:cNvPr id="19" name="Text 16"/>
-          <p:cNvSpPr txBox="1"/>
-          <p:nvPr/>
-        </p:nvSpPr>
-        <p:spPr>
-          <a:xfrm>
-            <a:off x="6278728" y="731520"/>
-            <a:ext cx="5410048" cy="457200"/>
-          </a:xfrm>
-          <a:prstGeom prst="rect">
-            <a:avLst/>
-          </a:prstGeom>
-          <a:noFill/>
-          <a:ln/>
-        </p:spPr>
-        <p:txBody>
-          <a:bodyPr wrap="square" lIns="0" tIns="0" rIns="0" bIns="0" rtlCol="0" anchor="t"/>
-          <a:lstStyle/>
-          <a:p>
-            <a:pPr indent="0" marL="0">
-              <a:buNone/>
-            </a:pPr>
-            <a:r>
-              <a:rPr lang="en-US" sz="2400" b="1" dirty="0">
-                <a:solidFill>
-                  <a:srgbClr val="0D1411"/>
-                </a:solidFill>
-                <a:latin typeface="Calibri" pitchFamily="34" charset="0"/>
-                <a:ea typeface="Calibri" pitchFamily="34" charset="-122"/>
-                <a:cs typeface="Calibri" pitchFamily="34" charset="-120"/>
-              </a:rPr>
-              <a:t>Baldan təsərrüfat ziyarətinə</a:t>
-            </a:r>
-            <a:endParaRPr lang="en-US" sz="2400" dirty="0"/>
-          </a:p>
-        </p:txBody>
-      </p:sp>
-      <p:sp>
-        <p:nvSpPr>
-          <p:cNvPr id="20" name="Text 17"/>
-          <p:cNvSpPr txBox="1"/>
-          <p:nvPr/>
-        </p:nvSpPr>
-        <p:spPr>
-          <a:xfrm>
-            <a:off x="6278728" y="1225296"/>
-            <a:ext cx="5410048" cy="585216"/>
-          </a:xfrm>
-          <a:prstGeom prst="rect">
-            <a:avLst/>
-          </a:prstGeom>
-          <a:noFill/>
-          <a:ln/>
-        </p:spPr>
-        <p:txBody>
-          <a:bodyPr wrap="square" lIns="0" tIns="0" rIns="0" bIns="0" rtlCol="0" anchor="t"/>
-          <a:lstStyle/>
-          <a:p>
-            <a:pPr indent="0" marL="0">
-              <a:buNone/>
-            </a:pPr>
-            <a:r>
-              <a:rPr lang="en-US" sz="1400" dirty="0">
-                <a:solidFill>
-                  <a:srgbClr val="4A5852"/>
-                </a:solidFill>
-                <a:latin typeface="Calibri" pitchFamily="34" charset="0"/>
-                <a:ea typeface="Calibri" pitchFamily="34" charset="-122"/>
-                <a:cs typeface="Calibri" pitchFamily="34" charset="-120"/>
-              </a:rPr>
-              <a:t>Bu təsərrüfatda nəyi yoxlamaq lazımdır. Sayt xəstəliyin adını demir. Harada baxmağı göstərir.</a:t>
-            </a:r>
-            <a:endParaRPr lang="en-US" sz="1400" dirty="0"/>
-          </a:p>
-        </p:txBody>
-      </p:sp>
-      <p:sp>
-        <p:nvSpPr>
-          <p:cNvPr id="21" name="Text 18"/>
-          <p:cNvSpPr txBox="1"/>
-          <p:nvPr/>
-        </p:nvSpPr>
-        <p:spPr>
-          <a:xfrm>
-            <a:off x="9631375" y="2261286"/>
+          <p:cNvPr id="22" name="Text 19"/>
+          <p:cNvSpPr txBox="1"/>
+          <p:nvPr/>
+        </p:nvSpPr>
+        <p:spPr>
+          <a:xfrm>
+            <a:off x="9631375" y="4455846"/>
             <a:ext cx="228600" cy="228600"/>
           </a:xfrm>
           <a:prstGeom prst="ellipse">
@@ -9384,7 +8676,7 @@
                 <a:ea typeface="Calibri" pitchFamily="34" charset="-122"/>
                 <a:cs typeface="Calibri" pitchFamily="34" charset="-120"/>
               </a:rPr>
-              <a:t>1</a:t>
+              <a:t>3</a:t>
             </a:r>
             <a:endParaRPr lang="en-US" sz="1000" dirty="0"/>
           </a:p>
@@ -9392,14 +8684,14 @@
       </p:sp>
       <p:sp>
         <p:nvSpPr>
-          <p:cNvPr id="22" name="Text 19"/>
-          <p:cNvSpPr txBox="1"/>
-          <p:nvPr/>
-        </p:nvSpPr>
-        <p:spPr>
-          <a:xfrm>
-            <a:off x="9960559" y="2265858"/>
-            <a:ext cx="1728216" cy="961726"/>
+          <p:cNvPr id="23" name="Text 20"/>
+          <p:cNvSpPr txBox="1"/>
+          <p:nvPr/>
+        </p:nvSpPr>
+        <p:spPr>
+          <a:xfrm>
+            <a:off x="9960559" y="4460418"/>
+            <a:ext cx="1728216" cy="1024128"/>
           </a:xfrm>
           <a:prstGeom prst="rect">
             <a:avLst/>
@@ -9426,7 +8718,7 @@
                 <a:ea typeface="Calibri" pitchFamily="34" charset="-122"/>
                 <a:cs typeface="Calibri" pitchFamily="34" charset="-120"/>
               </a:rPr>
-              <a:t>Ən təcili birinci</a:t>
+              <a:t>Təsərrüfata aparın</a:t>
             </a:r>
             <a:endParaRPr lang="en-US" sz="1300" dirty="0"/>
           </a:p>
@@ -9443,7 +8735,7 @@
                 <a:ea typeface="Calibri" pitchFamily="34" charset="-122"/>
                 <a:cs typeface="Calibri" pitchFamily="34" charset="-120"/>
               </a:rPr>
-              <a:t>Hər problem və qısa səbəbi.</a:t>
+              <a:t>Ziyarət üçün bir səhifə çap edin.</a:t>
             </a:r>
             <a:endParaRPr lang="en-US" sz="1300" dirty="0"/>
           </a:p>
@@ -9451,319 +8743,7 @@
       </p:sp>
       <p:sp>
         <p:nvSpPr>
-          <p:cNvPr id="23" name="Text 20"/>
-          <p:cNvSpPr txBox="1"/>
-          <p:nvPr/>
-        </p:nvSpPr>
-        <p:spPr>
-          <a:xfrm>
-            <a:off x="9631375" y="3296165"/>
-            <a:ext cx="228600" cy="228600"/>
-          </a:xfrm>
-          <a:prstGeom prst="ellipse">
-            <a:avLst/>
-          </a:prstGeom>
-          <a:solidFill>
-            <a:srgbClr val="114230"/>
-          </a:solidFill>
-          <a:ln w="15875">
-            <a:solidFill>
-              <a:srgbClr val="FFFFFF"/>
-            </a:solidFill>
-          </a:ln>
-        </p:spPr>
-        <p:txBody>
-          <a:bodyPr wrap="square" lIns="0" tIns="0" rIns="0" bIns="0" rtlCol="0" anchor="ctr"/>
-          <a:lstStyle/>
-          <a:p>
-            <a:pPr algn="ctr" indent="0" marL="0">
-              <a:buNone/>
-            </a:pPr>
-            <a:r>
-              <a:rPr lang="en-US" sz="1000" b="1" dirty="0">
-                <a:solidFill>
-                  <a:srgbClr val="FFFFFF"/>
-                </a:solidFill>
-                <a:latin typeface="Calibri" pitchFamily="34" charset="0"/>
-                <a:ea typeface="Calibri" pitchFamily="34" charset="-122"/>
-                <a:cs typeface="Calibri" pitchFamily="34" charset="-120"/>
-              </a:rPr>
-              <a:t>2</a:t>
-            </a:r>
-            <a:endParaRPr lang="en-US" sz="1000" dirty="0"/>
-          </a:p>
-        </p:txBody>
-      </p:sp>
-      <p:sp>
-        <p:nvSpPr>
-          <p:cNvPr id="24" name="Text 21"/>
-          <p:cNvSpPr txBox="1"/>
-          <p:nvPr/>
-        </p:nvSpPr>
-        <p:spPr>
-          <a:xfrm>
-            <a:off x="9960559" y="3300737"/>
-            <a:ext cx="1728216" cy="961726"/>
-          </a:xfrm>
-          <a:prstGeom prst="rect">
-            <a:avLst/>
-          </a:prstGeom>
-          <a:noFill/>
-          <a:ln/>
-        </p:spPr>
-        <p:txBody>
-          <a:bodyPr wrap="square" lIns="0" tIns="0" rIns="0" bIns="0" rtlCol="0" anchor="t"/>
-          <a:lstStyle/>
-          <a:p>
-            <a:pPr indent="0" marL="0">
-              <a:spcAft>
-                <a:spcPts val="200"/>
-              </a:spcAft>
-              <a:buNone/>
-            </a:pPr>
-            <a:r>
-              <a:rPr lang="en-US" sz="1300" b="1" dirty="0">
-                <a:solidFill>
-                  <a:srgbClr val="0D1411"/>
-                </a:solidFill>
-                <a:latin typeface="Calibri" pitchFamily="34" charset="0"/>
-                <a:ea typeface="Calibri" pitchFamily="34" charset="-122"/>
-                <a:cs typeface="Calibri" pitchFamily="34" charset="-120"/>
-              </a:rPr>
-              <a:t>Nə etməli</a:t>
-            </a:r>
-            <a:endParaRPr lang="en-US" sz="1300" dirty="0"/>
-          </a:p>
-          <a:p>
-            <a:pPr indent="0" marL="0">
-              <a:buNone/>
-            </a:pPr>
-            <a:r>
-              <a:rPr lang="en-US" sz="1150" dirty="0">
-                <a:solidFill>
-                  <a:srgbClr val="4A5852"/>
-                </a:solidFill>
-                <a:latin typeface="Calibri" pitchFamily="34" charset="0"/>
-                <a:ea typeface="Calibri" pitchFamily="34" charset="-122"/>
-                <a:cs typeface="Calibri" pitchFamily="34" charset="-120"/>
-              </a:rPr>
-              <a:t>Su çatışmazlığını, torpaqda duzu və ya zərərvericiləri axtarın.</a:t>
-            </a:r>
-            <a:endParaRPr lang="en-US" sz="1300" dirty="0"/>
-          </a:p>
-        </p:txBody>
-      </p:sp>
-      <p:sp>
-        <p:nvSpPr>
-          <p:cNvPr id="25" name="Text 22"/>
-          <p:cNvSpPr txBox="1"/>
-          <p:nvPr/>
-        </p:nvSpPr>
-        <p:spPr>
-          <a:xfrm>
-            <a:off x="9631375" y="4331043"/>
-            <a:ext cx="228600" cy="228600"/>
-          </a:xfrm>
-          <a:prstGeom prst="ellipse">
-            <a:avLst/>
-          </a:prstGeom>
-          <a:solidFill>
-            <a:srgbClr val="114230"/>
-          </a:solidFill>
-          <a:ln w="15875">
-            <a:solidFill>
-              <a:srgbClr val="FFFFFF"/>
-            </a:solidFill>
-          </a:ln>
-        </p:spPr>
-        <p:txBody>
-          <a:bodyPr wrap="square" lIns="0" tIns="0" rIns="0" bIns="0" rtlCol="0" anchor="ctr"/>
-          <a:lstStyle/>
-          <a:p>
-            <a:pPr algn="ctr" indent="0" marL="0">
-              <a:buNone/>
-            </a:pPr>
-            <a:r>
-              <a:rPr lang="en-US" sz="1000" b="1" dirty="0">
-                <a:solidFill>
-                  <a:srgbClr val="FFFFFF"/>
-                </a:solidFill>
-                <a:latin typeface="Calibri" pitchFamily="34" charset="0"/>
-                <a:ea typeface="Calibri" pitchFamily="34" charset="-122"/>
-                <a:cs typeface="Calibri" pitchFamily="34" charset="-120"/>
-              </a:rPr>
-              <a:t>3</a:t>
-            </a:r>
-            <a:endParaRPr lang="en-US" sz="1000" dirty="0"/>
-          </a:p>
-        </p:txBody>
-      </p:sp>
-      <p:sp>
-        <p:nvSpPr>
-          <p:cNvPr id="26" name="Text 23"/>
-          <p:cNvSpPr txBox="1"/>
-          <p:nvPr/>
-        </p:nvSpPr>
-        <p:spPr>
-          <a:xfrm>
-            <a:off x="9960559" y="4335615"/>
-            <a:ext cx="1728216" cy="961726"/>
-          </a:xfrm>
-          <a:prstGeom prst="rect">
-            <a:avLst/>
-          </a:prstGeom>
-          <a:noFill/>
-          <a:ln/>
-        </p:spPr>
-        <p:txBody>
-          <a:bodyPr wrap="square" lIns="0" tIns="0" rIns="0" bIns="0" rtlCol="0" anchor="t"/>
-          <a:lstStyle/>
-          <a:p>
-            <a:pPr indent="0" marL="0">
-              <a:spcAft>
-                <a:spcPts val="200"/>
-              </a:spcAft>
-              <a:buNone/>
-            </a:pPr>
-            <a:r>
-              <a:rPr lang="en-US" sz="1300" b="1" dirty="0">
-                <a:solidFill>
-                  <a:srgbClr val="0D1411"/>
-                </a:solidFill>
-                <a:latin typeface="Calibri" pitchFamily="34" charset="0"/>
-                <a:ea typeface="Calibri" pitchFamily="34" charset="-122"/>
-                <a:cs typeface="Calibri" pitchFamily="34" charset="-120"/>
-              </a:rPr>
-              <a:t>Təsərrüfata aparın</a:t>
-            </a:r>
-            <a:endParaRPr lang="en-US" sz="1300" dirty="0"/>
-          </a:p>
-          <a:p>
-            <a:pPr indent="0" marL="0">
-              <a:buNone/>
-            </a:pPr>
-            <a:r>
-              <a:rPr lang="en-US" sz="1150" dirty="0">
-                <a:solidFill>
-                  <a:srgbClr val="4A5852"/>
-                </a:solidFill>
-                <a:latin typeface="Calibri" pitchFamily="34" charset="0"/>
-                <a:ea typeface="Calibri" pitchFamily="34" charset="-122"/>
-                <a:cs typeface="Calibri" pitchFamily="34" charset="-120"/>
-              </a:rPr>
-              <a:t>Ziyarət üçün bir səhifə çap edin.</a:t>
-            </a:r>
-            <a:endParaRPr lang="en-US" sz="1300" dirty="0"/>
-          </a:p>
-        </p:txBody>
-      </p:sp>
-      <p:sp>
-        <p:nvSpPr>
-          <p:cNvPr id="27" name="Text 24"/>
-          <p:cNvSpPr txBox="1"/>
-          <p:nvPr/>
-        </p:nvSpPr>
-        <p:spPr>
-          <a:xfrm>
-            <a:off x="9631375" y="5365922"/>
-            <a:ext cx="228600" cy="228600"/>
-          </a:xfrm>
-          <a:prstGeom prst="ellipse">
-            <a:avLst/>
-          </a:prstGeom>
-          <a:solidFill>
-            <a:srgbClr val="114230"/>
-          </a:solidFill>
-          <a:ln w="15875">
-            <a:solidFill>
-              <a:srgbClr val="FFFFFF"/>
-            </a:solidFill>
-          </a:ln>
-        </p:spPr>
-        <p:txBody>
-          <a:bodyPr wrap="square" lIns="0" tIns="0" rIns="0" bIns="0" rtlCol="0" anchor="ctr"/>
-          <a:lstStyle/>
-          <a:p>
-            <a:pPr algn="ctr" indent="0" marL="0">
-              <a:buNone/>
-            </a:pPr>
-            <a:r>
-              <a:rPr lang="en-US" sz="1000" b="1" dirty="0">
-                <a:solidFill>
-                  <a:srgbClr val="FFFFFF"/>
-                </a:solidFill>
-                <a:latin typeface="Calibri" pitchFamily="34" charset="0"/>
-                <a:ea typeface="Calibri" pitchFamily="34" charset="-122"/>
-                <a:cs typeface="Calibri" pitchFamily="34" charset="-120"/>
-              </a:rPr>
-              <a:t>4</a:t>
-            </a:r>
-            <a:endParaRPr lang="en-US" sz="1000" dirty="0"/>
-          </a:p>
-        </p:txBody>
-      </p:sp>
-      <p:sp>
-        <p:nvSpPr>
-          <p:cNvPr id="28" name="Text 25"/>
-          <p:cNvSpPr txBox="1"/>
-          <p:nvPr/>
-        </p:nvSpPr>
-        <p:spPr>
-          <a:xfrm>
-            <a:off x="9960559" y="5370494"/>
-            <a:ext cx="1728216" cy="961726"/>
-          </a:xfrm>
-          <a:prstGeom prst="rect">
-            <a:avLst/>
-          </a:prstGeom>
-          <a:noFill/>
-          <a:ln/>
-        </p:spPr>
-        <p:txBody>
-          <a:bodyPr wrap="square" lIns="0" tIns="0" rIns="0" bIns="0" rtlCol="0" anchor="t"/>
-          <a:lstStyle/>
-          <a:p>
-            <a:pPr indent="0" marL="0">
-              <a:spcAft>
-                <a:spcPts val="200"/>
-              </a:spcAft>
-              <a:buNone/>
-            </a:pPr>
-            <a:r>
-              <a:rPr lang="en-US" sz="1300" b="1" dirty="0">
-                <a:solidFill>
-                  <a:srgbClr val="0D1411"/>
-                </a:solidFill>
-                <a:latin typeface="Calibri" pitchFamily="34" charset="0"/>
-                <a:ea typeface="Calibri" pitchFamily="34" charset="-122"/>
-                <a:cs typeface="Calibri" pitchFamily="34" charset="-120"/>
-              </a:rPr>
-              <a:t>Mümkün səbəb</a:t>
-            </a:r>
-            <a:endParaRPr lang="en-US" sz="1300" dirty="0"/>
-          </a:p>
-          <a:p>
-            <a:pPr indent="0" marL="0">
-              <a:buNone/>
-            </a:pPr>
-            <a:r>
-              <a:rPr lang="en-US" sz="1150" dirty="0">
-                <a:solidFill>
-                  <a:srgbClr val="4A5852"/>
-                </a:solidFill>
-                <a:latin typeface="Calibri" pitchFamily="34" charset="0"/>
-                <a:ea typeface="Calibri" pitchFamily="34" charset="-122"/>
-                <a:cs typeface="Calibri" pitchFamily="34" charset="-120"/>
-              </a:rPr>
-              <a:t>Təsərrüfat ona ayrılan suyun yalnız 70 faizini istifadə edib.</a:t>
-            </a:r>
-            <a:endParaRPr lang="en-US" sz="1300" dirty="0"/>
-          </a:p>
-        </p:txBody>
-      </p:sp>
-      <p:sp>
-        <p:nvSpPr>
-          <p:cNvPr id="30" name="Text 26"/>
+          <p:cNvPr id="25" name="Text 21"/>
           <p:cNvSpPr txBox="1"/>
           <p:nvPr/>
         </p:nvSpPr>
@@ -10075,7 +9055,7 @@
                 <a:ea typeface="Calibri" pitchFamily="34" charset="-122"/>
                 <a:cs typeface="Calibri" pitchFamily="34" charset="-120"/>
               </a:rPr>
-              <a:t>From the satellite, every season.</a:t>
+              <a:t>From the satellite imagery.</a:t>
             </a:r>
             <a:endParaRPr lang="en-US" sz="1500" dirty="0"/>
           </a:p>
@@ -10131,7 +9111,7 @@
                 <a:ea typeface="Calibri" pitchFamily="34" charset="-122"/>
                 <a:cs typeface="Calibri" pitchFamily="34" charset="-120"/>
               </a:rPr>
-              <a:t>Peykdən, hər mövsüm.</a:t>
+              <a:t>Peyk şəkillərindən.</a:t>
             </a:r>
             <a:endParaRPr lang="en-US" sz="1400" dirty="0"/>
           </a:p>
@@ -10811,7 +9791,7 @@
                 <a:ea typeface="Calibri" pitchFamily="34" charset="-122"/>
                 <a:cs typeface="Calibri" pitchFamily="34" charset="-120"/>
               </a:rPr>
-              <a:t>Your team visits</a:t>
+              <a:t>Your team reaches out</a:t>
             </a:r>
             <a:endParaRPr lang="en-US" sz="1500" dirty="0"/>
           </a:p>
@@ -10828,7 +9808,7 @@
                 <a:ea typeface="Calibri" pitchFamily="34" charset="-122"/>
                 <a:cs typeface="Calibri" pitchFamily="34" charset="-120"/>
               </a:rPr>
-              <a:t>With one page: what to check.</a:t>
+              <a:t>With relevant suggestions and a plan of action.</a:t>
             </a:r>
             <a:endParaRPr lang="en-US" sz="1500" dirty="0"/>
           </a:p>
@@ -10867,7 +9847,7 @@
                 <a:ea typeface="Calibri" pitchFamily="34" charset="-122"/>
                 <a:cs typeface="Calibri" pitchFamily="34" charset="-120"/>
               </a:rPr>
-              <a:t>Komandanız baş çəkir</a:t>
+              <a:t>Komandanız əlaqə saxlayır</a:t>
             </a:r>
             <a:endParaRPr lang="en-US" sz="1400" dirty="0"/>
           </a:p>
@@ -10884,7 +9864,7 @@
                 <a:ea typeface="Calibri" pitchFamily="34" charset="-122"/>
                 <a:cs typeface="Calibri" pitchFamily="34" charset="-120"/>
               </a:rPr>
-              <a:t>Bir səhifə ilə: nəyi yoxlamaq lazımdır.</a:t>
+              <a:t>Uyğun tövsiyələr və fəaliyyət planı ilə.</a:t>
             </a:r>
             <a:endParaRPr lang="en-US" sz="1400" dirty="0"/>
           </a:p>
@@ -10892,63 +9872,7 @@
       </p:sp>
       <p:sp>
         <p:nvSpPr>
-          <p:cNvPr id="31" name="Text 22"/>
-          <p:cNvSpPr txBox="1"/>
-          <p:nvPr/>
-        </p:nvSpPr>
-        <p:spPr>
-          <a:xfrm>
-            <a:off x="685800" y="5760720"/>
-            <a:ext cx="9601200" cy="685800"/>
-          </a:xfrm>
-          <a:prstGeom prst="rect">
-            <a:avLst/>
-          </a:prstGeom>
-          <a:noFill/>
-          <a:ln/>
-        </p:spPr>
-        <p:txBody>
-          <a:bodyPr wrap="square" lIns="0" tIns="0" rIns="0" bIns="0" rtlCol="0" anchor="t"/>
-          <a:lstStyle/>
-          <a:p>
-            <a:pPr indent="0" marL="0">
-              <a:buNone/>
-            </a:pPr>
-            <a:r>
-              <a:rPr lang="en-US" sz="1500" b="1" dirty="0">
-                <a:solidFill>
-                  <a:srgbClr val="FFFFFF"/>
-                </a:solidFill>
-                <a:latin typeface="Calibri" pitchFamily="34" charset="0"/>
-                <a:ea typeface="Calibri" pitchFamily="34" charset="-122"/>
-                <a:cs typeface="Calibri" pitchFamily="34" charset="-120"/>
-              </a:rPr>
-              <a:t>Next step: a live demo of the website.</a:t>
-            </a:r>
-            <a:endParaRPr lang="en-US" sz="1500" dirty="0"/>
-          </a:p>
-          <a:p>
-            <a:pPr indent="0" marL="0">
-              <a:buNone/>
-            </a:pPr>
-            <a:r>
-              <a:rPr lang="en-US" sz="1400" dirty="0">
-                <a:solidFill>
-                  <a:srgbClr val="BDE0D0"/>
-                </a:solidFill>
-                <a:latin typeface="Calibri" pitchFamily="34" charset="0"/>
-                <a:ea typeface="Calibri" pitchFamily="34" charset="-122"/>
-                <a:cs typeface="Calibri" pitchFamily="34" charset="-120"/>
-              </a:rPr>
-              <a:t>Növbəti addım: saytın canlı nümayişi.</a:t>
-            </a:r>
-            <a:endParaRPr lang="en-US" sz="1500" dirty="0"/>
-          </a:p>
-        </p:txBody>
-      </p:sp>
-      <p:sp>
-        <p:nvSpPr>
-          <p:cNvPr id="33" name="Text 23"/>
+          <p:cNvPr id="32" name="Text 22"/>
           <p:cNvSpPr txBox="1"/>
           <p:nvPr/>
         </p:nvSpPr>

</xml_diff>